<commit_message>
Add HTML BI path, benchmarks, and latest artifacts
</commit_message>
<xml_diff>
--- a/analytics_report.pptx
+++ b/analytics_report.pptx
@@ -3301,7 +3301,7 @@
                 </a:solidFill>
                 <a:latin typeface="Calibri"/>
               </a:rPr>
-              <a:t>Reducing Preventable Attrition: Targeting the 16% of employees at highest risk</a:t>
+              <a:t>Optimizing Operations with High-Fidelity Weather Intelligence</a:t>
             </a:r>
           </a:p>
         </p:txBody>
@@ -3336,7 +3336,7 @@
                 </a:solidFill>
                 <a:latin typeface="Calibri"/>
               </a:rPr>
-              <a:t>Executive Briefing</a:t>
+              <a:t>Analysis for Business Decision-Makers</a:t>
             </a:r>
           </a:p>
         </p:txBody>
@@ -3371,7 +3371,7 @@
                 </a:solidFill>
                 <a:latin typeface="Calibri"/>
               </a:rPr>
-              <a:t>June 01, 2026</a:t>
+              <a:t>June 26, 2026</a:t>
             </a:r>
           </a:p>
         </p:txBody>
@@ -3462,13 +3462,13 @@
           <a:p>
             <a:pPr algn="l"/>
             <a:r>
-              <a:rPr sz="1800" b="1" i="0">
+              <a:rPr sz="2000" b="1" i="0">
                 <a:solidFill>
                   <a:srgbClr val="15304C"/>
                 </a:solidFill>
                 <a:latin typeface="Calibri"/>
               </a:rPr>
-              <a:t>Priority recommendations: Immediate actions to reduce attrition in the highest-risk segments</a:t>
+              <a:t>Recommendations: Deploy Forecasting Tool and Rule-Based Scheduler</a:t>
             </a:r>
           </a:p>
         </p:txBody>
@@ -3591,7 +3591,7 @@
                 </a:solidFill>
                 <a:latin typeface="Calibri"/>
               </a:rPr>
-              <a:t>Launch a 90-day pilot focused on overtime and travel in Sales, then expand based on measured results</a:t>
+              <a:t>Prioritize implementing the high-accuracy model for solar energy and a simplified scheduler for outdoor operations</a:t>
             </a:r>
           </a:p>
         </p:txBody>
@@ -3749,7 +3749,7 @@
                 </a:solidFill>
                 <a:latin typeface="Calibri"/>
               </a:rPr>
-              <a:t>Action: Launch an immediate audit and action plan for overtime practices in the Sales</a:t>
+              <a:t>Action: Deploy the regression model for day-ahead solar radiation forecasting to</a:t>
             </a:r>
           </a:p>
         </p:txBody>
@@ -3784,7 +3784,7 @@
                 </a:solidFill>
                 <a:latin typeface="Calibri"/>
               </a:rPr>
-              <a:t>Owner: business owner | Trigger: segment enters the agreed</a:t>
+              <a:t>Track pilot outcome, adoption, guardrails, and stop/go criteria before scaling.</a:t>
             </a:r>
           </a:p>
         </p:txBody>
@@ -3819,7 +3819,7 @@
                 </a:solidFill>
                 <a:latin typeface="Calibri"/>
               </a:rPr>
-              <a:t>Trigger + guardrail required</a:t>
+              <a:t>Validation required</a:t>
             </a:r>
           </a:p>
         </p:txBody>
@@ -3977,7 +3977,7 @@
                 </a:solidFill>
                 <a:latin typeface="Calibri"/>
               </a:rPr>
-              <a:t>Action: Review and enhance support policies for employees who travel frequently</a:t>
+              <a:t>Action: Develop a simplified, rule-based scheduling tool for outdoor operations</a:t>
             </a:r>
           </a:p>
         </p:txBody>
@@ -4012,7 +4012,7 @@
                 </a:solidFill>
                 <a:latin typeface="Calibri"/>
               </a:rPr>
-              <a:t>Owner: business owner | Trigger: segment enters the agreed intervention</a:t>
+              <a:t>Track pilot outcome, adoption, guardrails, and stop/go criteria before scaling.</a:t>
             </a:r>
           </a:p>
         </p:txBody>
@@ -4047,7 +4047,7 @@
                 </a:solidFill>
                 <a:latin typeface="Calibri"/>
               </a:rPr>
-              <a:t>Trigger + guardrail required</a:t>
+              <a:t>Validation required</a:t>
             </a:r>
           </a:p>
         </p:txBody>
@@ -4205,7 +4205,7 @@
                 </a:solidFill>
                 <a:latin typeface="Calibri"/>
               </a:rPr>
-              <a:t>Action: Initiate a retention-focused review with the HR and Sales department leadership</a:t>
+              <a:t>Action: Initiate a data collection and model replication project for two adjacent</a:t>
             </a:r>
           </a:p>
         </p:txBody>
@@ -4240,7 +4240,7 @@
                 </a:solidFill>
                 <a:latin typeface="Calibri"/>
               </a:rPr>
-              <a:t>Owner: business owner | Trigger: segment enters the agreed</a:t>
+              <a:t>Owner: business</a:t>
             </a:r>
           </a:p>
         </p:txBody>
@@ -4275,7 +4275,7 @@
                 </a:solidFill>
                 <a:latin typeface="Calibri"/>
               </a:rPr>
-              <a:t>Trigger + guardrail required</a:t>
+              <a:t>Validation required</a:t>
             </a:r>
           </a:p>
         </p:txBody>
@@ -4353,7 +4353,7 @@
                 </a:solidFill>
                 <a:latin typeface="Calibri"/>
               </a:rPr>
-              <a:t>Reducing Preventable Attrition</a:t>
+              <a:t>Optimizing Operations with High-Fidelity Weather Intelligence</a:t>
             </a:r>
           </a:p>
         </p:txBody>
@@ -4443,13 +4443,13 @@
           <a:p>
             <a:pPr algn="l"/>
             <a:r>
-              <a:rPr sz="1800" b="1" i="0">
+              <a:rPr sz="2000" b="1" i="0">
                 <a:solidFill>
                   <a:srgbClr val="15304C"/>
                 </a:solidFill>
                 <a:latin typeface="Calibri"/>
               </a:rPr>
-              <a:t>Limitations and responsible use: Model identifies high-risk groups, not individual fate</a:t>
+              <a:t>Limitations: Geographic Specificity and Clear-Sky Focus Require Managed Expansion</a:t>
             </a:r>
           </a:p>
         </p:txBody>
@@ -4572,7 +4572,7 @@
                 </a:solidFill>
                 <a:latin typeface="Calibri"/>
               </a:rPr>
-              <a:t>Use insights to guide supportive program design for segments, not for individual performance management or automated decisions</a:t>
+              <a:t>The model's high performance is tied to a single location and predicts ideal conditions, not actual weather</a:t>
             </a:r>
           </a:p>
         </p:txBody>
@@ -4687,7 +4687,7 @@
                 </a:solidFill>
                 <a:latin typeface="Calibri"/>
               </a:rPr>
-              <a:t>Explanatory model only: test accuracy 81.9% trails the baseline 83.9%; use the rules to</a:t>
+              <a:t>Exploratory screening only: validate precision, recall, F1, and support before operational use</a:t>
             </a:r>
           </a:p>
         </p:txBody>
@@ -4802,7 +4802,7 @@
                 </a:solidFill>
                 <a:latin typeface="Calibri"/>
               </a:rPr>
-              <a:t>The predictive model's accuracy (81.9% test accuracy) is insufficient for reliably scoring individual employee</a:t>
+              <a:t>The model is geographically specific to a single point (021d49N, 039d18E)</a:t>
             </a:r>
           </a:p>
         </p:txBody>
@@ -4917,7 +4917,7 @@
                 </a:solidFill>
                 <a:latin typeface="Calibri"/>
               </a:rPr>
-              <a:t>The data is a static snapshot; it does not capture the temporal trends or</a:t>
+              <a:t>The model predicts clear-sky radiation (CLRSKY_SFC_SW_DWN), not actual radiation under cloudy conditions</a:t>
             </a:r>
           </a:p>
         </p:txBody>
@@ -5032,7 +5032,7 @@
                 </a:solidFill>
                 <a:latin typeface="Calibri"/>
               </a:rPr>
-              <a:t>Analysis shows correlation, not causation. While overtime and attrition are strongly linked</a:t>
+              <a:t>The dataset ends in December 2023. Future climate trends or anomalies may alter underlying</a:t>
             </a:r>
           </a:p>
         </p:txBody>
@@ -5110,7 +5110,7 @@
                 </a:solidFill>
                 <a:latin typeface="Calibri"/>
               </a:rPr>
-              <a:t>Reducing Preventable Attrition</a:t>
+              <a:t>Optimizing Operations with High-Fidelity Weather Intelligence</a:t>
             </a:r>
           </a:p>
         </p:txBody>
@@ -5249,7 +5249,7 @@
                 </a:solidFill>
                 <a:latin typeface="Calibri"/>
               </a:rPr>
-              <a:t>Summary: Preventable attrition is concentrated and addressable</a:t>
+              <a:t>Summary: Actionable Weather Intelligence from a Robust, Interpretable Model</a:t>
             </a:r>
           </a:p>
         </p:txBody>
@@ -5327,7 +5327,7 @@
                 </a:solidFill>
                 <a:latin typeface="Calibri"/>
               </a:rPr>
-              <a:t>By targeting the 16% of employees in high-risk segments defined by overtime and travel, we can launch focused, high-impact retention programs within the next.</a:t>
+              <a:t>Implement the high-accuracy solar radiation forecast and rule-based scheduler to reduce uncertainty in energy and outdoor operations.</a:t>
             </a:r>
           </a:p>
         </p:txBody>
@@ -5375,7 +5375,7 @@
                 </a:solidFill>
                 <a:latin typeface="Calibri"/>
               </a:rPr>
-              <a:t>Sales department attrition is 25.8%, highest among departments</a:t>
+              <a:t>Temperature shows clear warming trend and seasonal cycles over 17-year period</a:t>
             </a:r>
           </a:p>
           <a:p>
@@ -5400,7 +5400,7 @@
                 </a:solidFill>
                 <a:latin typeface="Calibri"/>
               </a:rPr>
-              <a:t>Approve and fund the 60-day overtime audit in Sales and the 90-day travel policy review as the highest-priority</a:t>
+              <a:t>Immediately deploy the high-accuracy solar radiation forecasting model for solar energy operations in the original</a:t>
             </a:r>
           </a:p>
           <a:p>
@@ -5425,7 +5425,7 @@
                 </a:solidFill>
                 <a:latin typeface="Calibri"/>
               </a:rPr>
-              <a:t>Employee attrition is a manageable cost center, not an inevitable fact</a:t>
+              <a:t>The weather data analysis has delivered a robust, interpretable predictive model that directly addresses the need</a:t>
             </a:r>
           </a:p>
         </p:txBody>
@@ -5556,7 +5556,7 @@
                 </a:solidFill>
                 <a:latin typeface="Calibri"/>
               </a:rPr>
-              <a:t>Analysis is based on a clean snapshot of 1,470 employees with 35 attributes</a:t>
+              <a:t>Foundation: A Complete, High-Quality Dataset Spanning 17 Years</a:t>
             </a:r>
           </a:p>
         </p:txBody>
@@ -5679,7 +5679,7 @@
                 </a:solidFill>
                 <a:latin typeface="Calibri"/>
               </a:rPr>
-              <a:t>The dataset provides a robust foundation for segmentation, revealing clear patterns in who leaves and why.</a:t>
+              <a:t>148,320 hourly records provide a robust, clean basis for modeling solar radiation and its key weather drivers.</a:t>
             </a:r>
           </a:p>
         </p:txBody>
@@ -5759,7 +5759,7 @@
                 </a:solidFill>
                 <a:latin typeface="Calibri"/>
               </a:rPr>
-              <a:t>1470</a:t>
+              <a:t>148320</a:t>
             </a:r>
           </a:p>
         </p:txBody>
@@ -5874,7 +5874,7 @@
                 </a:solidFill>
                 <a:latin typeface="Calibri"/>
               </a:rPr>
-              <a:t>35</a:t>
+              <a:t>8</a:t>
             </a:r>
           </a:p>
         </p:txBody>
@@ -5989,7 +5989,7 @@
                 </a:solidFill>
                 <a:latin typeface="Calibri"/>
               </a:rPr>
-              <a:t>Attrition</a:t>
+              <a:t>CLRSKY_SFC_SW_DWN</a:t>
             </a:r>
           </a:p>
         </p:txBody>
@@ -6152,7 +6152,7 @@
                 </a:solidFill>
                 <a:latin typeface="Calibri"/>
               </a:rPr>
-              <a:t>hr attrition</a:t>
+              <a:t>weather</a:t>
             </a:r>
           </a:p>
           <a:p>
@@ -6177,7 +6177,7 @@
                 </a:solidFill>
                 <a:latin typeface="Calibri"/>
               </a:rPr>
-              <a:t>Key fields include Age, Attrition, BusinessTravel, DailyRate, Department, DistanceFromHome, Education, EducationField</a:t>
+              <a:t>Key fields include YEAR, MO, DY, HR, CLRSKY_SFC_SW_DWN, T2M, RH2M, WS10M</a:t>
             </a:r>
           </a:p>
           <a:p>
@@ -6202,7 +6202,7 @@
                 </a:solidFill>
                 <a:latin typeface="Calibri"/>
               </a:rPr>
-              <a:t>Target field is Attrition</a:t>
+              <a:t>Target field is CLRSKY_SFC_SW_DWN</a:t>
             </a:r>
           </a:p>
         </p:txBody>
@@ -6330,7 +6330,7 @@
                 </a:solidFill>
                 <a:latin typeface="Calibri"/>
               </a:rPr>
-              <a:t>Dataset has 1470 rows and 35 columns with no missing values or duplicate rows.</a:t>
+              <a:t>Dataset has 148,320 hourly weather records from 2007 to 2023 with no missing values or duplicates.</a:t>
             </a:r>
           </a:p>
           <a:p>
@@ -6355,7 +6355,7 @@
                 </a:solidFill>
                 <a:latin typeface="Calibri"/>
               </a:rPr>
-              <a:t>Remove or flag constant columns: EmployeeCount, Over18...</a:t>
+              <a:t>Combine YEAR, MO, DY, HR into a single datetime column for time series analysis</a:t>
             </a:r>
           </a:p>
           <a:p>
@@ -6380,7 +6380,7 @@
                 </a:solidFill>
                 <a:latin typeface="Calibri"/>
               </a:rPr>
-              <a:t>Consider outlier treatment for columns like MonthlyIncome, TrainingTimesLastYear...</a:t>
+              <a:t>Investigate outliers in T2M and WS10M for data validity or extreme weather events</a:t>
             </a:r>
           </a:p>
           <a:p>
@@ -6405,7 +6405,7 @@
                 </a:solidFill>
                 <a:latin typeface="Calibri"/>
               </a:rPr>
-              <a:t>Ensure categorical variables (e.g., BusinessTravel, Department) are properly encoded for machine learning models</a:t>
+              <a:t>YEAR, MO, DY, HR are discrete numeric columns representing date and time components...</a:t>
             </a:r>
           </a:p>
         </p:txBody>
@@ -6483,7 +6483,7 @@
                 </a:solidFill>
                 <a:latin typeface="Calibri"/>
               </a:rPr>
-              <a:t>Reducing Preventable Attrition</a:t>
+              <a:t>Optimizing Operations with High-Fidelity Weather Intelligence</a:t>
             </a:r>
           </a:p>
         </p:txBody>
@@ -6573,13 +6573,13 @@
           <a:p>
             <a:pPr algn="l"/>
             <a:r>
-              <a:rPr sz="2300" b="1" i="0">
+              <a:rPr sz="1800" b="1" i="0">
                 <a:solidFill>
                   <a:srgbClr val="15304C"/>
                 </a:solidFill>
                 <a:latin typeface="Calibri"/>
               </a:rPr>
-              <a:t>Unplanned attrition costs exceed 150% of salary</a:t>
+              <a:t>Market Context: Weather Data is a Critical Input for Energy, Agriculture, and Logistics</a:t>
             </a:r>
           </a:p>
         </p:txBody>
@@ -6702,7 +6702,7 @@
                 </a:solidFill>
                 <a:latin typeface="Calibri"/>
               </a:rPr>
-              <a:t>Replacing employees is expensive and disruptive; preventing predictable turnover in key roles protects institutional knowledge and operational stability.</a:t>
+              <a:t>Short-range forecasting drives daily operations; solar radiation prediction is directly linked to renewable energy yield and outdoor activity scheduling.</a:t>
             </a:r>
           </a:p>
         </p:txBody>
@@ -6795,7 +6795,7 @@
                 </a:solidFill>
                 <a:latin typeface="Calibri"/>
               </a:rPr>
-              <a:t>The average attrition rate in the UK in 2025 was 19%, above the European average of 17.4%, representing</a:t>
+              <a:t>Short-range weather forecasting (1-3 days) holds a 34.24% market share in 2026 and is expected to depict the</a:t>
             </a:r>
           </a:p>
           <a:p>
@@ -6820,7 +6820,7 @@
                 </a:solidFill>
                 <a:latin typeface="Calibri"/>
               </a:rPr>
-              <a:t>For India's top-5 IT services companies, the attrition rate has stabilized at approximately 13% as of FY2025...</a:t>
+              <a:t>The short-range forecasting segment is anticipated to witness a significant CAGR of over 7% from 2026 to 2033</a:t>
             </a:r>
           </a:p>
           <a:p>
@@ -6845,7 +6845,7 @@
                 </a:solidFill>
                 <a:latin typeface="Calibri"/>
               </a:rPr>
-              <a:t>Consulting, legal, and IT roles have traditionally experienced high turnover</a:t>
+              <a:t>Extreme weather is ranked among the top risks for global business in 2026, just behind geopolitical conflict, per</a:t>
             </a:r>
           </a:p>
           <a:p>
@@ -6870,7 +6870,7 @@
                 </a:solidFill>
                 <a:latin typeface="Calibri"/>
               </a:rPr>
-              <a:t>Artificial intelligence is transforming attrition management from reactive to predictive</a:t>
+              <a:t>Extreme weather events are pressing global risks that necessitate business strategies for climate volatility and...</a:t>
             </a:r>
           </a:p>
         </p:txBody>
@@ -6985,7 +6985,7 @@
                 </a:solidFill>
                 <a:latin typeface="Calibri"/>
               </a:rPr>
-              <a:t>Replacing employees is expensive and disruptive; preventing predictable turnover in key roles protects institutional knowledge and operational stability.</a:t>
+              <a:t>Short-range forecasting drives daily operations; solar radiation prediction is directly linked to renewable energy yield and outdoor activity scheduling.</a:t>
             </a:r>
           </a:p>
         </p:txBody>
@@ -7063,7 +7063,7 @@
                 </a:solidFill>
                 <a:latin typeface="Calibri"/>
               </a:rPr>
-              <a:t>Reducing Preventable Attrition</a:t>
+              <a:t>Optimizing Operations with High-Fidelity Weather Intelligence</a:t>
             </a:r>
           </a:p>
         </p:txBody>
@@ -7153,13 +7153,13 @@
           <a:p>
             <a:pPr algn="l"/>
             <a:r>
-              <a:rPr sz="2300" b="1" i="0">
+              <a:rPr sz="2000" b="1" i="0">
                 <a:solidFill>
                   <a:srgbClr val="15304C"/>
                 </a:solidFill>
                 <a:latin typeface="Calibri"/>
               </a:rPr>
-              <a:t>Sales ranks highest on Attrition Rate at 20.6%</a:t>
+              <a:t>Monthly temperature shows warming trend from 2007-2023 with seasonal cycles</a:t>
             </a:r>
           </a:p>
         </p:txBody>
@@ -7216,7 +7216,7 @@
         <p:spPr>
           <a:xfrm>
             <a:off x="749808" y="1371600"/>
-            <a:ext cx="3657600" cy="4526280"/>
+            <a:ext cx="6583680" cy="4526280"/>
           </a:xfrm>
           <a:prstGeom prst="roundRect">
             <a:avLst/>
@@ -7252,184 +7252,40 @@
           </a:p>
         </p:txBody>
       </p:sp>
-      <p:sp>
-        <p:nvSpPr>
-          <p:cNvPr id="5" name="TextBox 4"/>
-          <p:cNvSpPr txBox="1"/>
-          <p:nvPr/>
-        </p:nvSpPr>
-        <p:spPr>
-          <a:xfrm>
-            <a:off x="987552" y="1664208"/>
-            <a:ext cx="3063240" cy="320040"/>
-          </a:xfrm>
-          <a:prstGeom prst="rect">
-            <a:avLst/>
-          </a:prstGeom>
-          <a:noFill/>
-        </p:spPr>
-        <p:txBody>
-          <a:bodyPr wrap="square" lIns="54864" rIns="54864" tIns="27432" bIns="27432">
-            <a:spAutoFit/>
-          </a:bodyPr>
-          <a:lstStyle/>
-          <a:p>
-            <a:pPr algn="l"/>
-            <a:r>
-              <a:rPr sz="1400" b="1" i="0">
-                <a:solidFill>
-                  <a:srgbClr val="15304C"/>
-                </a:solidFill>
-                <a:latin typeface="Calibri"/>
-              </a:rPr>
-              <a:t>Readout</a:t>
-            </a:r>
-          </a:p>
-        </p:txBody>
-      </p:sp>
-      <p:sp>
-        <p:nvSpPr>
-          <p:cNvPr id="6" name="TextBox 5"/>
-          <p:cNvSpPr txBox="1"/>
-          <p:nvPr/>
-        </p:nvSpPr>
-        <p:spPr>
-          <a:xfrm>
-            <a:off x="987552" y="2084831"/>
-            <a:ext cx="3054096" cy="841248"/>
-          </a:xfrm>
-          <a:prstGeom prst="rect">
-            <a:avLst/>
-          </a:prstGeom>
-          <a:noFill/>
-        </p:spPr>
-        <p:txBody>
-          <a:bodyPr wrap="square" lIns="54864" rIns="54864" tIns="27432" bIns="27432">
-            <a:spAutoFit/>
-          </a:bodyPr>
-          <a:lstStyle/>
-          <a:p>
-            <a:pPr algn="l"/>
-            <a:r>
-              <a:rPr sz="1200" b="1" i="0">
-                <a:solidFill>
-                  <a:srgbClr val="1F2730"/>
-                </a:solidFill>
-                <a:latin typeface="Calibri"/>
-              </a:rPr>
-              <a:t>Sales department attrition is 25.8%, highest among departments.</a:t>
-            </a:r>
-          </a:p>
-        </p:txBody>
-      </p:sp>
-      <p:sp>
-        <p:nvSpPr>
-          <p:cNvPr id="7" name="TextBox 6"/>
-          <p:cNvSpPr txBox="1"/>
-          <p:nvPr/>
-        </p:nvSpPr>
-        <p:spPr>
-          <a:xfrm>
-            <a:off x="950976" y="3127248"/>
-            <a:ext cx="3127248" cy="1920240"/>
-          </a:xfrm>
-          <a:prstGeom prst="rect">
-            <a:avLst/>
-          </a:prstGeom>
-          <a:noFill/>
-        </p:spPr>
-        <p:txBody>
-          <a:bodyPr wrap="square" lIns="36576" rIns="36576" tIns="18288" bIns="18288">
-            <a:spAutoFit/>
-          </a:bodyPr>
-          <a:lstStyle/>
-          <a:p>
-            <a:pPr>
-              <a:spcAft>
-                <a:spcPts val="700"/>
-              </a:spcAft>
-            </a:pPr>
-            <a:r>
-              <a:rPr sz="1000" b="1">
-                <a:solidFill>
-                  <a:srgbClr val="2C65A4"/>
-                </a:solidFill>
-                <a:latin typeface="Calibri"/>
-              </a:rPr>
-              <a:t>- </a:t>
-            </a:r>
-            <a:r>
-              <a:rPr sz="1000">
-                <a:solidFill>
-                  <a:srgbClr val="1F2730"/>
-                </a:solidFill>
-                <a:latin typeface="Calibri"/>
-              </a:rPr>
-              <a:t>Sales department attrition is 25.8%, highest among departments</a:t>
-            </a:r>
-          </a:p>
-          <a:p>
-            <a:pPr>
-              <a:spcAft>
-                <a:spcPts val="700"/>
-              </a:spcAft>
-            </a:pPr>
-            <a:r>
-              <a:rPr sz="1000" b="1">
-                <a:solidFill>
-                  <a:srgbClr val="2C65A4"/>
-                </a:solidFill>
-                <a:latin typeface="Calibri"/>
-              </a:rPr>
-              <a:t>- </a:t>
-            </a:r>
-            <a:r>
-              <a:rPr sz="1000">
-                <a:solidFill>
-                  <a:srgbClr val="1F2730"/>
-                </a:solidFill>
-                <a:latin typeface="Calibri"/>
-              </a:rPr>
-              <a:t>Focus retention efforts on Sales department</a:t>
-            </a:r>
-          </a:p>
-          <a:p>
-            <a:pPr>
-              <a:spcAft>
-                <a:spcPts val="700"/>
-              </a:spcAft>
-            </a:pPr>
-            <a:r>
-              <a:rPr sz="1000" b="1">
-                <a:solidFill>
-                  <a:srgbClr val="2C65A4"/>
-                </a:solidFill>
-                <a:latin typeface="Calibri"/>
-              </a:rPr>
-              <a:t>- </a:t>
-            </a:r>
-            <a:r>
-              <a:rPr sz="1000">
-                <a:solidFill>
-                  <a:srgbClr val="1F2730"/>
-                </a:solidFill>
-                <a:latin typeface="Calibri"/>
-              </a:rPr>
-              <a:t>Attrition Rate by Department</a:t>
-            </a:r>
-          </a:p>
-        </p:txBody>
-      </p:sp>
-      <p:sp>
-        <p:nvSpPr>
-          <p:cNvPr id="8" name="Rounded Rectangle 7"/>
+      <p:pic>
+        <p:nvPicPr>
+          <p:cNvPr id="5" name="Picture 4" descr="figure_1_20260626_181544.png"/>
+          <p:cNvPicPr>
+            <a:picLocks noChangeAspect="1"/>
+          </p:cNvPicPr>
+          <p:nvPr/>
+        </p:nvPicPr>
+        <p:blipFill>
+          <a:blip r:embed="rId2"/>
+          <a:stretch>
+            <a:fillRect/>
+          </a:stretch>
+        </p:blipFill>
+        <p:spPr>
+          <a:xfrm>
+            <a:off x="886967" y="1902675"/>
+            <a:ext cx="6309360" cy="3464128"/>
+          </a:xfrm>
+          <a:prstGeom prst="rect">
+            <a:avLst/>
+          </a:prstGeom>
+        </p:spPr>
+      </p:pic>
+      <p:sp>
+        <p:nvSpPr>
+          <p:cNvPr id="6" name="Rounded Rectangle 5"/>
           <p:cNvSpPr/>
           <p:nvPr/>
         </p:nvSpPr>
         <p:spPr>
           <a:xfrm>
-            <a:off x="4709160" y="1371600"/>
-            <a:ext cx="6583680" cy="4526280"/>
+            <a:off x="7635240" y="1371600"/>
+            <a:ext cx="3657600" cy="4526280"/>
           </a:xfrm>
           <a:prstGeom prst="roundRect">
             <a:avLst/>
@@ -7467,14 +7323,84 @@
       </p:sp>
       <p:sp>
         <p:nvSpPr>
+          <p:cNvPr id="7" name="TextBox 6"/>
+          <p:cNvSpPr txBox="1"/>
+          <p:nvPr/>
+        </p:nvSpPr>
+        <p:spPr>
+          <a:xfrm>
+            <a:off x="7882127" y="1664208"/>
+            <a:ext cx="3063240" cy="320040"/>
+          </a:xfrm>
+          <a:prstGeom prst="rect">
+            <a:avLst/>
+          </a:prstGeom>
+          <a:noFill/>
+        </p:spPr>
+        <p:txBody>
+          <a:bodyPr wrap="square" lIns="54864" rIns="54864" tIns="27432" bIns="27432">
+            <a:spAutoFit/>
+          </a:bodyPr>
+          <a:lstStyle/>
+          <a:p>
+            <a:pPr algn="l"/>
+            <a:r>
+              <a:rPr sz="1400" b="1" i="0">
+                <a:solidFill>
+                  <a:srgbClr val="15304C"/>
+                </a:solidFill>
+                <a:latin typeface="Calibri"/>
+              </a:rPr>
+              <a:t>Insight</a:t>
+            </a:r>
+          </a:p>
+        </p:txBody>
+      </p:sp>
+      <p:sp>
+        <p:nvSpPr>
+          <p:cNvPr id="8" name="TextBox 7"/>
+          <p:cNvSpPr txBox="1"/>
+          <p:nvPr/>
+        </p:nvSpPr>
+        <p:spPr>
+          <a:xfrm>
+            <a:off x="7882127" y="2084831"/>
+            <a:ext cx="3054096" cy="841248"/>
+          </a:xfrm>
+          <a:prstGeom prst="rect">
+            <a:avLst/>
+          </a:prstGeom>
+          <a:noFill/>
+        </p:spPr>
+        <p:txBody>
+          <a:bodyPr wrap="square" lIns="54864" rIns="54864" tIns="27432" bIns="27432">
+            <a:spAutoFit/>
+          </a:bodyPr>
+          <a:lstStyle/>
+          <a:p>
+            <a:pPr algn="l"/>
+            <a:r>
+              <a:rPr sz="1200" b="1" i="0">
+                <a:solidFill>
+                  <a:srgbClr val="1F2730"/>
+                </a:solidFill>
+                <a:latin typeface="Calibri"/>
+              </a:rPr>
+              <a:t>Monthly temperature shows warming trend from 2007-2023 with seasonal cycles.</a:t>
+            </a:r>
+          </a:p>
+        </p:txBody>
+      </p:sp>
+      <p:sp>
+        <p:nvSpPr>
           <p:cNvPr id="9" name="TextBox 8"/>
           <p:cNvSpPr txBox="1"/>
           <p:nvPr/>
         </p:nvSpPr>
         <p:spPr>
           <a:xfrm>
-            <a:off x="4892040" y="1554480"/>
-            <a:ext cx="6217920" cy="256032"/>
+            <a:off x="7845552" y="3127248"/>
+            <a:ext cx="3127248" cy="1920240"/>
           </a:xfrm>
           <a:prstGeom prst="rect">
             <a:avLst/>
@@ -7482,34 +7408,47 @@
           <a:noFill/>
         </p:spPr>
         <p:txBody>
-          <a:bodyPr wrap="square" lIns="9144" rIns="9144" tIns="0" bIns="0">
+          <a:bodyPr wrap="square" lIns="36576" rIns="36576" tIns="18288" bIns="18288">
             <a:spAutoFit/>
           </a:bodyPr>
           <a:lstStyle/>
           <a:p>
-            <a:pPr algn="l"/>
+            <a:pPr>
+              <a:spcAft>
+                <a:spcPts val="700"/>
+              </a:spcAft>
+            </a:pPr>
             <a:r>
               <a:rPr sz="1000" b="1">
                 <a:solidFill>
-                  <a:srgbClr val="15304C"/>
-                </a:solidFill>
-                <a:latin typeface="Calibri"/>
-              </a:rPr>
-              <a:t>Attrition Rate by Department</a:t>
-            </a:r>
-          </a:p>
-        </p:txBody>
-      </p:sp>
-      <p:sp>
-        <p:nvSpPr>
-          <p:cNvPr id="10" name="reconstructed_chart_gridline"/>
+                  <a:srgbClr val="2C65A4"/>
+                </a:solidFill>
+                <a:latin typeface="Calibri"/>
+              </a:rPr>
+              <a:t>- </a:t>
+            </a:r>
+            <a:r>
+              <a:rPr sz="1000">
+                <a:solidFill>
+                  <a:srgbClr val="1F2730"/>
+                </a:solidFill>
+                <a:latin typeface="Calibri"/>
+              </a:rPr>
+              <a:t>Monthly temperature shows warming trend from 2007-2023 with seasonal cycles</a:t>
+            </a:r>
+          </a:p>
+        </p:txBody>
+      </p:sp>
+      <p:sp>
+        <p:nvSpPr>
+          <p:cNvPr id="10" name="Rectangle 9"/>
           <p:cNvSpPr/>
           <p:nvPr/>
         </p:nvSpPr>
         <p:spPr>
           <a:xfrm>
-            <a:off x="5193792" y="2011680"/>
-            <a:ext cx="5742432" cy="5486"/>
+            <a:off x="658368" y="6291072"/>
+            <a:ext cx="10881360" cy="10972"/>
           </a:xfrm>
           <a:prstGeom prst="rect">
             <a:avLst/>
@@ -7545,631 +7484,7 @@
       </p:sp>
       <p:sp>
         <p:nvSpPr>
-          <p:cNvPr id="11" name="reconstructed_chart_gridline"/>
-          <p:cNvSpPr/>
-          <p:nvPr/>
-        </p:nvSpPr>
-        <p:spPr>
-          <a:xfrm>
-            <a:off x="5193792" y="3020568"/>
-            <a:ext cx="5742432" cy="5486"/>
-          </a:xfrm>
-          <a:prstGeom prst="rect">
-            <a:avLst/>
-          </a:prstGeom>
-          <a:solidFill>
-            <a:srgbClr val="D1D7DC"/>
-          </a:solidFill>
-          <a:ln>
-            <a:noFill/>
-          </a:ln>
-        </p:spPr>
-        <p:style>
-          <a:lnRef idx="1">
-            <a:schemeClr val="accent1"/>
-          </a:lnRef>
-          <a:fillRef idx="3">
-            <a:schemeClr val="accent1"/>
-          </a:fillRef>
-          <a:effectRef idx="2">
-            <a:schemeClr val="accent1"/>
-          </a:effectRef>
-          <a:fontRef idx="minor">
-            <a:schemeClr val="lt1"/>
-          </a:fontRef>
-        </p:style>
-        <p:txBody>
-          <a:bodyPr rtlCol="0" anchor="ctr"/>
-          <a:lstStyle/>
-          <a:p>
-            <a:pPr algn="ctr"/>
-          </a:p>
-        </p:txBody>
-      </p:sp>
-      <p:sp>
-        <p:nvSpPr>
-          <p:cNvPr id="12" name="reconstructed_chart_gridline"/>
-          <p:cNvSpPr/>
-          <p:nvPr/>
-        </p:nvSpPr>
-        <p:spPr>
-          <a:xfrm>
-            <a:off x="5193792" y="4029456"/>
-            <a:ext cx="5742432" cy="5486"/>
-          </a:xfrm>
-          <a:prstGeom prst="rect">
-            <a:avLst/>
-          </a:prstGeom>
-          <a:solidFill>
-            <a:srgbClr val="D1D7DC"/>
-          </a:solidFill>
-          <a:ln>
-            <a:noFill/>
-          </a:ln>
-        </p:spPr>
-        <p:style>
-          <a:lnRef idx="1">
-            <a:schemeClr val="accent1"/>
-          </a:lnRef>
-          <a:fillRef idx="3">
-            <a:schemeClr val="accent1"/>
-          </a:fillRef>
-          <a:effectRef idx="2">
-            <a:schemeClr val="accent1"/>
-          </a:effectRef>
-          <a:fontRef idx="minor">
-            <a:schemeClr val="lt1"/>
-          </a:fontRef>
-        </p:style>
-        <p:txBody>
-          <a:bodyPr rtlCol="0" anchor="ctr"/>
-          <a:lstStyle/>
-          <a:p>
-            <a:pPr algn="ctr"/>
-          </a:p>
-        </p:txBody>
-      </p:sp>
-      <p:sp>
-        <p:nvSpPr>
-          <p:cNvPr id="13" name="reconstructed_chart_gridline"/>
-          <p:cNvSpPr/>
-          <p:nvPr/>
-        </p:nvSpPr>
-        <p:spPr>
-          <a:xfrm>
-            <a:off x="5193792" y="5038344"/>
-            <a:ext cx="5742432" cy="5486"/>
-          </a:xfrm>
-          <a:prstGeom prst="rect">
-            <a:avLst/>
-          </a:prstGeom>
-          <a:solidFill>
-            <a:srgbClr val="D1D7DC"/>
-          </a:solidFill>
-          <a:ln>
-            <a:noFill/>
-          </a:ln>
-        </p:spPr>
-        <p:style>
-          <a:lnRef idx="1">
-            <a:schemeClr val="accent1"/>
-          </a:lnRef>
-          <a:fillRef idx="3">
-            <a:schemeClr val="accent1"/>
-          </a:fillRef>
-          <a:effectRef idx="2">
-            <a:schemeClr val="accent1"/>
-          </a:effectRef>
-          <a:fontRef idx="minor">
-            <a:schemeClr val="lt1"/>
-          </a:fontRef>
-        </p:style>
-        <p:txBody>
-          <a:bodyPr rtlCol="0" anchor="ctr"/>
-          <a:lstStyle/>
-          <a:p>
-            <a:pPr algn="ctr"/>
-          </a:p>
-        </p:txBody>
-      </p:sp>
-      <p:sp>
-        <p:nvSpPr>
-          <p:cNvPr id="14" name="reconstructed_chart_axis"/>
-          <p:cNvSpPr/>
-          <p:nvPr/>
-        </p:nvSpPr>
-        <p:spPr>
-          <a:xfrm>
-            <a:off x="5193792" y="5038344"/>
-            <a:ext cx="5742432" cy="10972"/>
-          </a:xfrm>
-          <a:prstGeom prst="rect">
-            <a:avLst/>
-          </a:prstGeom>
-          <a:solidFill>
-            <a:srgbClr val="D1D7DC"/>
-          </a:solidFill>
-          <a:ln>
-            <a:noFill/>
-          </a:ln>
-        </p:spPr>
-        <p:style>
-          <a:lnRef idx="1">
-            <a:schemeClr val="accent1"/>
-          </a:lnRef>
-          <a:fillRef idx="3">
-            <a:schemeClr val="accent1"/>
-          </a:fillRef>
-          <a:effectRef idx="2">
-            <a:schemeClr val="accent1"/>
-          </a:effectRef>
-          <a:fontRef idx="minor">
-            <a:schemeClr val="lt1"/>
-          </a:fontRef>
-        </p:style>
-        <p:txBody>
-          <a:bodyPr rtlCol="0" anchor="ctr"/>
-          <a:lstStyle/>
-          <a:p>
-            <a:pPr algn="ctr"/>
-          </a:p>
-        </p:txBody>
-      </p:sp>
-      <p:sp>
-        <p:nvSpPr>
-          <p:cNvPr id="15" name="reconstructed_chart_bar"/>
-          <p:cNvSpPr/>
-          <p:nvPr/>
-        </p:nvSpPr>
-        <p:spPr>
-          <a:xfrm>
-            <a:off x="5193792" y="2957229"/>
-            <a:ext cx="1865376" cy="2081114"/>
-          </a:xfrm>
-          <a:prstGeom prst="rect">
-            <a:avLst/>
-          </a:prstGeom>
-          <a:solidFill>
-            <a:srgbClr val="2C65A4"/>
-          </a:solidFill>
-          <a:ln>
-            <a:noFill/>
-          </a:ln>
-        </p:spPr>
-        <p:style>
-          <a:lnRef idx="1">
-            <a:schemeClr val="accent1"/>
-          </a:lnRef>
-          <a:fillRef idx="3">
-            <a:schemeClr val="accent1"/>
-          </a:fillRef>
-          <a:effectRef idx="2">
-            <a:schemeClr val="accent1"/>
-          </a:effectRef>
-          <a:fontRef idx="minor">
-            <a:schemeClr val="lt1"/>
-          </a:fontRef>
-        </p:style>
-        <p:txBody>
-          <a:bodyPr rtlCol="0" anchor="ctr"/>
-          <a:lstStyle/>
-          <a:p>
-            <a:pPr algn="ctr"/>
-          </a:p>
-        </p:txBody>
-      </p:sp>
-      <p:sp>
-        <p:nvSpPr>
-          <p:cNvPr id="16" name="TextBox 15"/>
-          <p:cNvSpPr txBox="1"/>
-          <p:nvPr/>
-        </p:nvSpPr>
-        <p:spPr>
-          <a:xfrm>
-            <a:off x="5157216" y="2737773"/>
-            <a:ext cx="1938528" cy="155448"/>
-          </a:xfrm>
-          <a:prstGeom prst="rect">
-            <a:avLst/>
-          </a:prstGeom>
-          <a:noFill/>
-        </p:spPr>
-        <p:txBody>
-          <a:bodyPr wrap="square" lIns="9144" rIns="9144" tIns="0" bIns="0">
-            <a:spAutoFit/>
-          </a:bodyPr>
-          <a:lstStyle/>
-          <a:p>
-            <a:pPr algn="ctr"/>
-            <a:r>
-              <a:rPr sz="700" b="0">
-                <a:solidFill>
-                  <a:srgbClr val="5E6974"/>
-                </a:solidFill>
-                <a:latin typeface="Calibri"/>
-              </a:rPr>
-              <a:t>0.206278</a:t>
-            </a:r>
-          </a:p>
-        </p:txBody>
-      </p:sp>
-      <p:sp>
-        <p:nvSpPr>
-          <p:cNvPr id="17" name="TextBox 16"/>
-          <p:cNvSpPr txBox="1"/>
-          <p:nvPr/>
-        </p:nvSpPr>
-        <p:spPr>
-          <a:xfrm>
-            <a:off x="5138928" y="5093208"/>
-            <a:ext cx="1975104" cy="347472"/>
-          </a:xfrm>
-          <a:prstGeom prst="rect">
-            <a:avLst/>
-          </a:prstGeom>
-          <a:noFill/>
-        </p:spPr>
-        <p:txBody>
-          <a:bodyPr wrap="square" lIns="9144" rIns="9144" tIns="0" bIns="0">
-            <a:spAutoFit/>
-          </a:bodyPr>
-          <a:lstStyle/>
-          <a:p>
-            <a:pPr algn="ctr"/>
-            <a:r>
-              <a:rPr sz="700" b="0">
-                <a:solidFill>
-                  <a:srgbClr val="5E6974"/>
-                </a:solidFill>
-                <a:latin typeface="Calibri"/>
-              </a:rPr>
-              <a:t>Sales</a:t>
-            </a:r>
-          </a:p>
-        </p:txBody>
-      </p:sp>
-      <p:sp>
-        <p:nvSpPr>
-          <p:cNvPr id="18" name="reconstructed_chart_bar"/>
-          <p:cNvSpPr/>
-          <p:nvPr/>
-        </p:nvSpPr>
-        <p:spPr>
-          <a:xfrm>
-            <a:off x="7132320" y="3116652"/>
-            <a:ext cx="1865376" cy="1921691"/>
-          </a:xfrm>
-          <a:prstGeom prst="rect">
-            <a:avLst/>
-          </a:prstGeom>
-          <a:solidFill>
-            <a:srgbClr val="35807F"/>
-          </a:solidFill>
-          <a:ln>
-            <a:noFill/>
-          </a:ln>
-        </p:spPr>
-        <p:style>
-          <a:lnRef idx="1">
-            <a:schemeClr val="accent1"/>
-          </a:lnRef>
-          <a:fillRef idx="3">
-            <a:schemeClr val="accent1"/>
-          </a:fillRef>
-          <a:effectRef idx="2">
-            <a:schemeClr val="accent1"/>
-          </a:effectRef>
-          <a:fontRef idx="minor">
-            <a:schemeClr val="lt1"/>
-          </a:fontRef>
-        </p:style>
-        <p:txBody>
-          <a:bodyPr rtlCol="0" anchor="ctr"/>
-          <a:lstStyle/>
-          <a:p>
-            <a:pPr algn="ctr"/>
-          </a:p>
-        </p:txBody>
-      </p:sp>
-      <p:sp>
-        <p:nvSpPr>
-          <p:cNvPr id="19" name="TextBox 18"/>
-          <p:cNvSpPr txBox="1"/>
-          <p:nvPr/>
-        </p:nvSpPr>
-        <p:spPr>
-          <a:xfrm>
-            <a:off x="7095744" y="2897196"/>
-            <a:ext cx="1938528" cy="155448"/>
-          </a:xfrm>
-          <a:prstGeom prst="rect">
-            <a:avLst/>
-          </a:prstGeom>
-          <a:noFill/>
-        </p:spPr>
-        <p:txBody>
-          <a:bodyPr wrap="square" lIns="9144" rIns="9144" tIns="0" bIns="0">
-            <a:spAutoFit/>
-          </a:bodyPr>
-          <a:lstStyle/>
-          <a:p>
-            <a:pPr algn="ctr"/>
-            <a:r>
-              <a:rPr sz="700" b="0">
-                <a:solidFill>
-                  <a:srgbClr val="5E6974"/>
-                </a:solidFill>
-                <a:latin typeface="Calibri"/>
-              </a:rPr>
-              <a:t>0.190476</a:t>
-            </a:r>
-          </a:p>
-        </p:txBody>
-      </p:sp>
-      <p:sp>
-        <p:nvSpPr>
-          <p:cNvPr id="20" name="TextBox 19"/>
-          <p:cNvSpPr txBox="1"/>
-          <p:nvPr/>
-        </p:nvSpPr>
-        <p:spPr>
-          <a:xfrm>
-            <a:off x="7077456" y="5093208"/>
-            <a:ext cx="1975104" cy="347472"/>
-          </a:xfrm>
-          <a:prstGeom prst="rect">
-            <a:avLst/>
-          </a:prstGeom>
-          <a:noFill/>
-        </p:spPr>
-        <p:txBody>
-          <a:bodyPr wrap="square" lIns="9144" rIns="9144" tIns="0" bIns="0">
-            <a:spAutoFit/>
-          </a:bodyPr>
-          <a:lstStyle/>
-          <a:p>
-            <a:pPr algn="ctr"/>
-            <a:r>
-              <a:rPr sz="700" b="0">
-                <a:solidFill>
-                  <a:srgbClr val="5E6974"/>
-                </a:solidFill>
-                <a:latin typeface="Calibri"/>
-              </a:rPr>
-              <a:t>Human Resources</a:t>
-            </a:r>
-          </a:p>
-        </p:txBody>
-      </p:sp>
-      <p:sp>
-        <p:nvSpPr>
-          <p:cNvPr id="21" name="reconstructed_chart_bar"/>
-          <p:cNvSpPr/>
-          <p:nvPr/>
-        </p:nvSpPr>
-        <p:spPr>
-          <a:xfrm>
-            <a:off x="9070848" y="3642068"/>
-            <a:ext cx="1865376" cy="1396275"/>
-          </a:xfrm>
-          <a:prstGeom prst="rect">
-            <a:avLst/>
-          </a:prstGeom>
-          <a:solidFill>
-            <a:srgbClr val="BB9241"/>
-          </a:solidFill>
-          <a:ln>
-            <a:noFill/>
-          </a:ln>
-        </p:spPr>
-        <p:style>
-          <a:lnRef idx="1">
-            <a:schemeClr val="accent1"/>
-          </a:lnRef>
-          <a:fillRef idx="3">
-            <a:schemeClr val="accent1"/>
-          </a:fillRef>
-          <a:effectRef idx="2">
-            <a:schemeClr val="accent1"/>
-          </a:effectRef>
-          <a:fontRef idx="minor">
-            <a:schemeClr val="lt1"/>
-          </a:fontRef>
-        </p:style>
-        <p:txBody>
-          <a:bodyPr rtlCol="0" anchor="ctr"/>
-          <a:lstStyle/>
-          <a:p>
-            <a:pPr algn="ctr"/>
-          </a:p>
-        </p:txBody>
-      </p:sp>
-      <p:sp>
-        <p:nvSpPr>
-          <p:cNvPr id="22" name="TextBox 21"/>
-          <p:cNvSpPr txBox="1"/>
-          <p:nvPr/>
-        </p:nvSpPr>
-        <p:spPr>
-          <a:xfrm>
-            <a:off x="9034272" y="3422612"/>
-            <a:ext cx="1938528" cy="155448"/>
-          </a:xfrm>
-          <a:prstGeom prst="rect">
-            <a:avLst/>
-          </a:prstGeom>
-          <a:noFill/>
-        </p:spPr>
-        <p:txBody>
-          <a:bodyPr wrap="square" lIns="9144" rIns="9144" tIns="0" bIns="0">
-            <a:spAutoFit/>
-          </a:bodyPr>
-          <a:lstStyle/>
-          <a:p>
-            <a:pPr algn="ctr"/>
-            <a:r>
-              <a:rPr sz="700" b="0">
-                <a:solidFill>
-                  <a:srgbClr val="5E6974"/>
-                </a:solidFill>
-                <a:latin typeface="Calibri"/>
-              </a:rPr>
-              <a:t>0.138398</a:t>
-            </a:r>
-          </a:p>
-        </p:txBody>
-      </p:sp>
-      <p:sp>
-        <p:nvSpPr>
-          <p:cNvPr id="23" name="TextBox 22"/>
-          <p:cNvSpPr txBox="1"/>
-          <p:nvPr/>
-        </p:nvSpPr>
-        <p:spPr>
-          <a:xfrm>
-            <a:off x="9015984" y="5093208"/>
-            <a:ext cx="1975104" cy="347472"/>
-          </a:xfrm>
-          <a:prstGeom prst="rect">
-            <a:avLst/>
-          </a:prstGeom>
-          <a:noFill/>
-        </p:spPr>
-        <p:txBody>
-          <a:bodyPr wrap="square" lIns="9144" rIns="9144" tIns="0" bIns="0">
-            <a:spAutoFit/>
-          </a:bodyPr>
-          <a:lstStyle/>
-          <a:p>
-            <a:pPr algn="ctr"/>
-            <a:r>
-              <a:rPr sz="700" b="0">
-                <a:solidFill>
-                  <a:srgbClr val="5E6974"/>
-                </a:solidFill>
-                <a:latin typeface="Calibri"/>
-              </a:rPr>
-              <a:t>Research &amp;...</a:t>
-            </a:r>
-          </a:p>
-        </p:txBody>
-      </p:sp>
-      <p:sp>
-        <p:nvSpPr>
-          <p:cNvPr id="24" name="TextBox 23"/>
-          <p:cNvSpPr txBox="1"/>
-          <p:nvPr/>
-        </p:nvSpPr>
-        <p:spPr>
-          <a:xfrm>
-            <a:off x="5257800" y="5550408"/>
-            <a:ext cx="5486400" cy="146304"/>
-          </a:xfrm>
-          <a:prstGeom prst="rect">
-            <a:avLst/>
-          </a:prstGeom>
-          <a:noFill/>
-        </p:spPr>
-        <p:txBody>
-          <a:bodyPr wrap="square" lIns="9144" rIns="9144" tIns="0" bIns="0">
-            <a:spAutoFit/>
-          </a:bodyPr>
-          <a:lstStyle/>
-          <a:p>
-            <a:pPr algn="ctr"/>
-            <a:r>
-              <a:rPr sz="700" b="0">
-                <a:solidFill>
-                  <a:srgbClr val="5E6974"/>
-                </a:solidFill>
-                <a:latin typeface="Calibri"/>
-              </a:rPr>
-              <a:t>Department</a:t>
-            </a:r>
-          </a:p>
-        </p:txBody>
-      </p:sp>
-      <p:sp>
-        <p:nvSpPr>
-          <p:cNvPr id="25" name="TextBox 24"/>
-          <p:cNvSpPr txBox="1"/>
-          <p:nvPr/>
-        </p:nvSpPr>
-        <p:spPr>
-          <a:xfrm>
-            <a:off x="4882896" y="1865376"/>
-            <a:ext cx="1463040" cy="146304"/>
-          </a:xfrm>
-          <a:prstGeom prst="rect">
-            <a:avLst/>
-          </a:prstGeom>
-          <a:noFill/>
-        </p:spPr>
-        <p:txBody>
-          <a:bodyPr wrap="square" lIns="9144" rIns="9144" tIns="0" bIns="0">
-            <a:spAutoFit/>
-          </a:bodyPr>
-          <a:lstStyle/>
-          <a:p>
-            <a:pPr algn="l"/>
-            <a:r>
-              <a:rPr sz="700" b="0">
-                <a:solidFill>
-                  <a:srgbClr val="5E6974"/>
-                </a:solidFill>
-                <a:latin typeface="Calibri"/>
-              </a:rPr>
-              <a:t>Attrition Rate</a:t>
-            </a:r>
-          </a:p>
-        </p:txBody>
-      </p:sp>
-      <p:sp>
-        <p:nvSpPr>
-          <p:cNvPr id="26" name="Rectangle 25"/>
-          <p:cNvSpPr/>
-          <p:nvPr/>
-        </p:nvSpPr>
-        <p:spPr>
-          <a:xfrm>
-            <a:off x="658368" y="6291072"/>
-            <a:ext cx="10881360" cy="10972"/>
-          </a:xfrm>
-          <a:prstGeom prst="rect">
-            <a:avLst/>
-          </a:prstGeom>
-          <a:solidFill>
-            <a:srgbClr val="D1D7DC"/>
-          </a:solidFill>
-          <a:ln>
-            <a:noFill/>
-          </a:ln>
-        </p:spPr>
-        <p:style>
-          <a:lnRef idx="1">
-            <a:schemeClr val="accent1"/>
-          </a:lnRef>
-          <a:fillRef idx="3">
-            <a:schemeClr val="accent1"/>
-          </a:fillRef>
-          <a:effectRef idx="2">
-            <a:schemeClr val="accent1"/>
-          </a:effectRef>
-          <a:fontRef idx="minor">
-            <a:schemeClr val="lt1"/>
-          </a:fontRef>
-        </p:style>
-        <p:txBody>
-          <a:bodyPr rtlCol="0" anchor="ctr"/>
-          <a:lstStyle/>
-          <a:p>
-            <a:pPr algn="ctr"/>
-          </a:p>
-        </p:txBody>
-      </p:sp>
-      <p:sp>
-        <p:nvSpPr>
-          <p:cNvPr id="27" name="TextBox 26"/>
+          <p:cNvPr id="11" name="TextBox 10"/>
           <p:cNvSpPr txBox="1"/>
           <p:nvPr/>
         </p:nvSpPr>
@@ -8197,14 +7512,14 @@
                 </a:solidFill>
                 <a:latin typeface="Calibri"/>
               </a:rPr>
-              <a:t>Reducing Preventable Attrition</a:t>
-            </a:r>
-          </a:p>
-        </p:txBody>
-      </p:sp>
-      <p:sp>
-        <p:nvSpPr>
-          <p:cNvPr id="28" name="TextBox 27"/>
+              <a:t>Optimizing Operations with High-Fidelity Weather Intelligence</a:t>
+            </a:r>
+          </a:p>
+        </p:txBody>
+      </p:sp>
+      <p:sp>
+        <p:nvSpPr>
+          <p:cNvPr id="12" name="TextBox 11"/>
           <p:cNvSpPr txBox="1"/>
           <p:nvPr/>
         </p:nvSpPr>
@@ -8287,13 +7602,13 @@
           <a:p>
             <a:pPr algn="l"/>
             <a:r>
-              <a:rPr sz="2300" b="1" i="0">
+              <a:rPr sz="2000" b="1" i="0">
                 <a:solidFill>
                   <a:srgbClr val="15304C"/>
                 </a:solidFill>
                 <a:latin typeface="Calibri"/>
               </a:rPr>
-              <a:t>Overtime employees have 30.5% attrition rate</a:t>
+              <a:t>Clear seasonal pattern with peak temperatures in summer months (June-August)</a:t>
             </a:r>
           </a:p>
         </p:txBody>
@@ -8350,7 +7665,7 @@
         <p:spPr>
           <a:xfrm>
             <a:off x="749808" y="1371600"/>
-            <a:ext cx="6583680" cy="4526280"/>
+            <a:ext cx="3657600" cy="4526280"/>
           </a:xfrm>
           <a:prstGeom prst="roundRect">
             <a:avLst/>
@@ -8394,8 +7709,8 @@
         </p:nvSpPr>
         <p:spPr>
           <a:xfrm>
-            <a:off x="932688" y="1554480"/>
-            <a:ext cx="6217920" cy="256032"/>
+            <a:off x="987552" y="1664208"/>
+            <a:ext cx="3063240" cy="320040"/>
           </a:xfrm>
           <a:prstGeom prst="rect">
             <a:avLst/>
@@ -8403,292 +7718,34 @@
           <a:noFill/>
         </p:spPr>
         <p:txBody>
-          <a:bodyPr wrap="square" lIns="9144" rIns="9144" tIns="0" bIns="0">
+          <a:bodyPr wrap="square" lIns="54864" rIns="54864" tIns="27432" bIns="27432">
             <a:spAutoFit/>
           </a:bodyPr>
           <a:lstStyle/>
           <a:p>
             <a:pPr algn="l"/>
             <a:r>
-              <a:rPr sz="1000" b="1">
+              <a:rPr sz="1400" b="1" i="0">
                 <a:solidFill>
                   <a:srgbClr val="15304C"/>
                 </a:solidFill>
                 <a:latin typeface="Calibri"/>
               </a:rPr>
-              <a:t>Attrition Rate by Overtime Status</a:t>
-            </a:r>
-          </a:p>
-        </p:txBody>
-      </p:sp>
-      <p:sp>
-        <p:nvSpPr>
-          <p:cNvPr id="6" name="reconstructed_chart_gridline"/>
-          <p:cNvSpPr/>
-          <p:nvPr/>
-        </p:nvSpPr>
-        <p:spPr>
-          <a:xfrm>
-            <a:off x="1234440" y="2011680"/>
-            <a:ext cx="5742432" cy="5486"/>
-          </a:xfrm>
-          <a:prstGeom prst="rect">
-            <a:avLst/>
-          </a:prstGeom>
-          <a:solidFill>
-            <a:srgbClr val="D1D7DC"/>
-          </a:solidFill>
-          <a:ln>
-            <a:noFill/>
-          </a:ln>
-        </p:spPr>
-        <p:style>
-          <a:lnRef idx="1">
-            <a:schemeClr val="accent1"/>
-          </a:lnRef>
-          <a:fillRef idx="3">
-            <a:schemeClr val="accent1"/>
-          </a:fillRef>
-          <a:effectRef idx="2">
-            <a:schemeClr val="accent1"/>
-          </a:effectRef>
-          <a:fontRef idx="minor">
-            <a:schemeClr val="lt1"/>
-          </a:fontRef>
-        </p:style>
-        <p:txBody>
-          <a:bodyPr rtlCol="0" anchor="ctr"/>
-          <a:lstStyle/>
-          <a:p>
-            <a:pPr algn="ctr"/>
-          </a:p>
-        </p:txBody>
-      </p:sp>
-      <p:sp>
-        <p:nvSpPr>
-          <p:cNvPr id="7" name="reconstructed_chart_gridline"/>
-          <p:cNvSpPr/>
-          <p:nvPr/>
-        </p:nvSpPr>
-        <p:spPr>
-          <a:xfrm>
-            <a:off x="1234440" y="3020568"/>
-            <a:ext cx="5742432" cy="5486"/>
-          </a:xfrm>
-          <a:prstGeom prst="rect">
-            <a:avLst/>
-          </a:prstGeom>
-          <a:solidFill>
-            <a:srgbClr val="D1D7DC"/>
-          </a:solidFill>
-          <a:ln>
-            <a:noFill/>
-          </a:ln>
-        </p:spPr>
-        <p:style>
-          <a:lnRef idx="1">
-            <a:schemeClr val="accent1"/>
-          </a:lnRef>
-          <a:fillRef idx="3">
-            <a:schemeClr val="accent1"/>
-          </a:fillRef>
-          <a:effectRef idx="2">
-            <a:schemeClr val="accent1"/>
-          </a:effectRef>
-          <a:fontRef idx="minor">
-            <a:schemeClr val="lt1"/>
-          </a:fontRef>
-        </p:style>
-        <p:txBody>
-          <a:bodyPr rtlCol="0" anchor="ctr"/>
-          <a:lstStyle/>
-          <a:p>
-            <a:pPr algn="ctr"/>
-          </a:p>
-        </p:txBody>
-      </p:sp>
-      <p:sp>
-        <p:nvSpPr>
-          <p:cNvPr id="8" name="reconstructed_chart_gridline"/>
-          <p:cNvSpPr/>
-          <p:nvPr/>
-        </p:nvSpPr>
-        <p:spPr>
-          <a:xfrm>
-            <a:off x="1234440" y="4029456"/>
-            <a:ext cx="5742432" cy="5486"/>
-          </a:xfrm>
-          <a:prstGeom prst="rect">
-            <a:avLst/>
-          </a:prstGeom>
-          <a:solidFill>
-            <a:srgbClr val="D1D7DC"/>
-          </a:solidFill>
-          <a:ln>
-            <a:noFill/>
-          </a:ln>
-        </p:spPr>
-        <p:style>
-          <a:lnRef idx="1">
-            <a:schemeClr val="accent1"/>
-          </a:lnRef>
-          <a:fillRef idx="3">
-            <a:schemeClr val="accent1"/>
-          </a:fillRef>
-          <a:effectRef idx="2">
-            <a:schemeClr val="accent1"/>
-          </a:effectRef>
-          <a:fontRef idx="minor">
-            <a:schemeClr val="lt1"/>
-          </a:fontRef>
-        </p:style>
-        <p:txBody>
-          <a:bodyPr rtlCol="0" anchor="ctr"/>
-          <a:lstStyle/>
-          <a:p>
-            <a:pPr algn="ctr"/>
-          </a:p>
-        </p:txBody>
-      </p:sp>
-      <p:sp>
-        <p:nvSpPr>
-          <p:cNvPr id="9" name="reconstructed_chart_gridline"/>
-          <p:cNvSpPr/>
-          <p:nvPr/>
-        </p:nvSpPr>
-        <p:spPr>
-          <a:xfrm>
-            <a:off x="1234440" y="5038344"/>
-            <a:ext cx="5742432" cy="5486"/>
-          </a:xfrm>
-          <a:prstGeom prst="rect">
-            <a:avLst/>
-          </a:prstGeom>
-          <a:solidFill>
-            <a:srgbClr val="D1D7DC"/>
-          </a:solidFill>
-          <a:ln>
-            <a:noFill/>
-          </a:ln>
-        </p:spPr>
-        <p:style>
-          <a:lnRef idx="1">
-            <a:schemeClr val="accent1"/>
-          </a:lnRef>
-          <a:fillRef idx="3">
-            <a:schemeClr val="accent1"/>
-          </a:fillRef>
-          <a:effectRef idx="2">
-            <a:schemeClr val="accent1"/>
-          </a:effectRef>
-          <a:fontRef idx="minor">
-            <a:schemeClr val="lt1"/>
-          </a:fontRef>
-        </p:style>
-        <p:txBody>
-          <a:bodyPr rtlCol="0" anchor="ctr"/>
-          <a:lstStyle/>
-          <a:p>
-            <a:pPr algn="ctr"/>
-          </a:p>
-        </p:txBody>
-      </p:sp>
-      <p:sp>
-        <p:nvSpPr>
-          <p:cNvPr id="10" name="reconstructed_chart_axis"/>
-          <p:cNvSpPr/>
-          <p:nvPr/>
-        </p:nvSpPr>
-        <p:spPr>
-          <a:xfrm>
-            <a:off x="1234440" y="5038344"/>
-            <a:ext cx="5742432" cy="10972"/>
-          </a:xfrm>
-          <a:prstGeom prst="rect">
-            <a:avLst/>
-          </a:prstGeom>
-          <a:solidFill>
-            <a:srgbClr val="D1D7DC"/>
-          </a:solidFill>
-          <a:ln>
-            <a:noFill/>
-          </a:ln>
-        </p:spPr>
-        <p:style>
-          <a:lnRef idx="1">
-            <a:schemeClr val="accent1"/>
-          </a:lnRef>
-          <a:fillRef idx="3">
-            <a:schemeClr val="accent1"/>
-          </a:fillRef>
-          <a:effectRef idx="2">
-            <a:schemeClr val="accent1"/>
-          </a:effectRef>
-          <a:fontRef idx="minor">
-            <a:schemeClr val="lt1"/>
-          </a:fontRef>
-        </p:style>
-        <p:txBody>
-          <a:bodyPr rtlCol="0" anchor="ctr"/>
-          <a:lstStyle/>
-          <a:p>
-            <a:pPr algn="ctr"/>
-          </a:p>
-        </p:txBody>
-      </p:sp>
-      <p:sp>
-        <p:nvSpPr>
-          <p:cNvPr id="11" name="reconstructed_chart_bar"/>
-          <p:cNvSpPr/>
-          <p:nvPr/>
-        </p:nvSpPr>
-        <p:spPr>
-          <a:xfrm>
-            <a:off x="1234440" y="2728330"/>
-            <a:ext cx="2834640" cy="2310013"/>
-          </a:xfrm>
-          <a:prstGeom prst="rect">
-            <a:avLst/>
-          </a:prstGeom>
-          <a:solidFill>
-            <a:srgbClr val="2C65A4"/>
-          </a:solidFill>
-          <a:ln>
-            <a:noFill/>
-          </a:ln>
-        </p:spPr>
-        <p:style>
-          <a:lnRef idx="1">
-            <a:schemeClr val="accent1"/>
-          </a:lnRef>
-          <a:fillRef idx="3">
-            <a:schemeClr val="accent1"/>
-          </a:fillRef>
-          <a:effectRef idx="2">
-            <a:schemeClr val="accent1"/>
-          </a:effectRef>
-          <a:fontRef idx="minor">
-            <a:schemeClr val="lt1"/>
-          </a:fontRef>
-        </p:style>
-        <p:txBody>
-          <a:bodyPr rtlCol="0" anchor="ctr"/>
-          <a:lstStyle/>
-          <a:p>
-            <a:pPr algn="ctr"/>
-          </a:p>
-        </p:txBody>
-      </p:sp>
-      <p:sp>
-        <p:nvSpPr>
-          <p:cNvPr id="12" name="TextBox 11"/>
+              <a:t>Readout</a:t>
+            </a:r>
+          </a:p>
+        </p:txBody>
+      </p:sp>
+      <p:sp>
+        <p:nvSpPr>
+          <p:cNvPr id="6" name="TextBox 5"/>
           <p:cNvSpPr txBox="1"/>
           <p:nvPr/>
         </p:nvSpPr>
         <p:spPr>
           <a:xfrm>
-            <a:off x="1197864" y="2508874"/>
-            <a:ext cx="2907792" cy="155448"/>
+            <a:off x="987552" y="2084831"/>
+            <a:ext cx="3054096" cy="841248"/>
           </a:xfrm>
           <a:prstGeom prst="rect">
             <a:avLst/>
@@ -8696,34 +7753,34 @@
           <a:noFill/>
         </p:spPr>
         <p:txBody>
-          <a:bodyPr wrap="square" lIns="9144" rIns="9144" tIns="0" bIns="0">
+          <a:bodyPr wrap="square" lIns="54864" rIns="54864" tIns="27432" bIns="27432">
             <a:spAutoFit/>
           </a:bodyPr>
           <a:lstStyle/>
           <a:p>
-            <a:pPr algn="ctr"/>
-            <a:r>
-              <a:rPr sz="700" b="0">
-                <a:solidFill>
-                  <a:srgbClr val="5E6974"/>
-                </a:solidFill>
-                <a:latin typeface="Calibri"/>
-              </a:rPr>
-              <a:t>0.305288</a:t>
-            </a:r>
-          </a:p>
-        </p:txBody>
-      </p:sp>
-      <p:sp>
-        <p:nvSpPr>
-          <p:cNvPr id="13" name="TextBox 12"/>
+            <a:pPr algn="l"/>
+            <a:r>
+              <a:rPr sz="1200" b="1" i="0">
+                <a:solidFill>
+                  <a:srgbClr val="1F2730"/>
+                </a:solidFill>
+                <a:latin typeface="Calibri"/>
+              </a:rPr>
+              <a:t>Clear seasonal pattern with peak temperatures in summer months (June-August).</a:t>
+            </a:r>
+          </a:p>
+        </p:txBody>
+      </p:sp>
+      <p:sp>
+        <p:nvSpPr>
+          <p:cNvPr id="7" name="TextBox 6"/>
           <p:cNvSpPr txBox="1"/>
           <p:nvPr/>
         </p:nvSpPr>
         <p:spPr>
           <a:xfrm>
-            <a:off x="1179576" y="5093208"/>
-            <a:ext cx="2944368" cy="347472"/>
+            <a:off x="950976" y="3127248"/>
+            <a:ext cx="3127248" cy="1920240"/>
           </a:xfrm>
           <a:prstGeom prst="rect">
             <a:avLst/>
@@ -8731,217 +7788,47 @@
           <a:noFill/>
         </p:spPr>
         <p:txBody>
-          <a:bodyPr wrap="square" lIns="9144" rIns="9144" tIns="0" bIns="0">
+          <a:bodyPr wrap="square" lIns="36576" rIns="36576" tIns="18288" bIns="18288">
             <a:spAutoFit/>
           </a:bodyPr>
           <a:lstStyle/>
           <a:p>
-            <a:pPr algn="ctr"/>
-            <a:r>
-              <a:rPr sz="700" b="0">
-                <a:solidFill>
-                  <a:srgbClr val="5E6974"/>
-                </a:solidFill>
-                <a:latin typeface="Calibri"/>
-              </a:rPr>
-              <a:t>Yes</a:t>
-            </a:r>
-          </a:p>
-        </p:txBody>
-      </p:sp>
-      <p:sp>
-        <p:nvSpPr>
-          <p:cNvPr id="14" name="reconstructed_chart_bar"/>
+            <a:pPr>
+              <a:spcAft>
+                <a:spcPts val="700"/>
+              </a:spcAft>
+            </a:pPr>
+            <a:r>
+              <a:rPr sz="1000" b="1">
+                <a:solidFill>
+                  <a:srgbClr val="2C65A4"/>
+                </a:solidFill>
+                <a:latin typeface="Calibri"/>
+              </a:rPr>
+              <a:t>- </a:t>
+            </a:r>
+            <a:r>
+              <a:rPr sz="1000">
+                <a:solidFill>
+                  <a:srgbClr val="1F2730"/>
+                </a:solidFill>
+                <a:latin typeface="Calibri"/>
+              </a:rPr>
+              <a:t>Clear seasonal pattern with peak temperatures in summer months (June-August)</a:t>
+            </a:r>
+          </a:p>
+        </p:txBody>
+      </p:sp>
+      <p:sp>
+        <p:nvSpPr>
+          <p:cNvPr id="8" name="Rounded Rectangle 7"/>
           <p:cNvSpPr/>
           <p:nvPr/>
         </p:nvSpPr>
         <p:spPr>
           <a:xfrm>
-            <a:off x="4142232" y="4248654"/>
-            <a:ext cx="2834640" cy="789689"/>
-          </a:xfrm>
-          <a:prstGeom prst="rect">
-            <a:avLst/>
-          </a:prstGeom>
-          <a:solidFill>
-            <a:srgbClr val="35807F"/>
-          </a:solidFill>
-          <a:ln>
-            <a:noFill/>
-          </a:ln>
-        </p:spPr>
-        <p:style>
-          <a:lnRef idx="1">
-            <a:schemeClr val="accent1"/>
-          </a:lnRef>
-          <a:fillRef idx="3">
-            <a:schemeClr val="accent1"/>
-          </a:fillRef>
-          <a:effectRef idx="2">
-            <a:schemeClr val="accent1"/>
-          </a:effectRef>
-          <a:fontRef idx="minor">
-            <a:schemeClr val="lt1"/>
-          </a:fontRef>
-        </p:style>
-        <p:txBody>
-          <a:bodyPr rtlCol="0" anchor="ctr"/>
-          <a:lstStyle/>
-          <a:p>
-            <a:pPr algn="ctr"/>
-          </a:p>
-        </p:txBody>
-      </p:sp>
-      <p:sp>
-        <p:nvSpPr>
-          <p:cNvPr id="15" name="TextBox 14"/>
-          <p:cNvSpPr txBox="1"/>
-          <p:nvPr/>
-        </p:nvSpPr>
-        <p:spPr>
-          <a:xfrm>
-            <a:off x="4105656" y="4029198"/>
-            <a:ext cx="2907792" cy="155448"/>
-          </a:xfrm>
-          <a:prstGeom prst="rect">
-            <a:avLst/>
-          </a:prstGeom>
-          <a:noFill/>
-        </p:spPr>
-        <p:txBody>
-          <a:bodyPr wrap="square" lIns="9144" rIns="9144" tIns="0" bIns="0">
-            <a:spAutoFit/>
-          </a:bodyPr>
-          <a:lstStyle/>
-          <a:p>
-            <a:pPr algn="ctr"/>
-            <a:r>
-              <a:rPr sz="700" b="0">
-                <a:solidFill>
-                  <a:srgbClr val="5E6974"/>
-                </a:solidFill>
-                <a:latin typeface="Calibri"/>
-              </a:rPr>
-              <a:t>0.104364</a:t>
-            </a:r>
-          </a:p>
-        </p:txBody>
-      </p:sp>
-      <p:sp>
-        <p:nvSpPr>
-          <p:cNvPr id="16" name="TextBox 15"/>
-          <p:cNvSpPr txBox="1"/>
-          <p:nvPr/>
-        </p:nvSpPr>
-        <p:spPr>
-          <a:xfrm>
-            <a:off x="4087368" y="5093208"/>
-            <a:ext cx="2944368" cy="347472"/>
-          </a:xfrm>
-          <a:prstGeom prst="rect">
-            <a:avLst/>
-          </a:prstGeom>
-          <a:noFill/>
-        </p:spPr>
-        <p:txBody>
-          <a:bodyPr wrap="square" lIns="9144" rIns="9144" tIns="0" bIns="0">
-            <a:spAutoFit/>
-          </a:bodyPr>
-          <a:lstStyle/>
-          <a:p>
-            <a:pPr algn="ctr"/>
-            <a:r>
-              <a:rPr sz="700" b="0">
-                <a:solidFill>
-                  <a:srgbClr val="5E6974"/>
-                </a:solidFill>
-                <a:latin typeface="Calibri"/>
-              </a:rPr>
-              <a:t>No</a:t>
-            </a:r>
-          </a:p>
-        </p:txBody>
-      </p:sp>
-      <p:sp>
-        <p:nvSpPr>
-          <p:cNvPr id="17" name="TextBox 16"/>
-          <p:cNvSpPr txBox="1"/>
-          <p:nvPr/>
-        </p:nvSpPr>
-        <p:spPr>
-          <a:xfrm>
-            <a:off x="1298448" y="5550408"/>
-            <a:ext cx="5486400" cy="146304"/>
-          </a:xfrm>
-          <a:prstGeom prst="rect">
-            <a:avLst/>
-          </a:prstGeom>
-          <a:noFill/>
-        </p:spPr>
-        <p:txBody>
-          <a:bodyPr wrap="square" lIns="9144" rIns="9144" tIns="0" bIns="0">
-            <a:spAutoFit/>
-          </a:bodyPr>
-          <a:lstStyle/>
-          <a:p>
-            <a:pPr algn="ctr"/>
-            <a:r>
-              <a:rPr sz="700" b="0">
-                <a:solidFill>
-                  <a:srgbClr val="5E6974"/>
-                </a:solidFill>
-                <a:latin typeface="Calibri"/>
-              </a:rPr>
-              <a:t>Overtime</a:t>
-            </a:r>
-          </a:p>
-        </p:txBody>
-      </p:sp>
-      <p:sp>
-        <p:nvSpPr>
-          <p:cNvPr id="18" name="TextBox 17"/>
-          <p:cNvSpPr txBox="1"/>
-          <p:nvPr/>
-        </p:nvSpPr>
-        <p:spPr>
-          <a:xfrm>
-            <a:off x="923544" y="1865376"/>
-            <a:ext cx="1463040" cy="146304"/>
-          </a:xfrm>
-          <a:prstGeom prst="rect">
-            <a:avLst/>
-          </a:prstGeom>
-          <a:noFill/>
-        </p:spPr>
-        <p:txBody>
-          <a:bodyPr wrap="square" lIns="9144" rIns="9144" tIns="0" bIns="0">
-            <a:spAutoFit/>
-          </a:bodyPr>
-          <a:lstStyle/>
-          <a:p>
-            <a:pPr algn="l"/>
-            <a:r>
-              <a:rPr sz="700" b="0">
-                <a:solidFill>
-                  <a:srgbClr val="5E6974"/>
-                </a:solidFill>
-                <a:latin typeface="Calibri"/>
-              </a:rPr>
-              <a:t>Attrition Rate</a:t>
-            </a:r>
-          </a:p>
-        </p:txBody>
-      </p:sp>
-      <p:sp>
-        <p:nvSpPr>
-          <p:cNvPr id="19" name="Rounded Rectangle 18"/>
-          <p:cNvSpPr/>
-          <p:nvPr/>
-        </p:nvSpPr>
-        <p:spPr>
-          <a:xfrm>
-            <a:off x="7635240" y="1371600"/>
-            <a:ext cx="3657600" cy="4526280"/>
+            <a:off x="4709160" y="1371600"/>
+            <a:ext cx="6583680" cy="4526280"/>
           </a:xfrm>
           <a:prstGeom prst="roundRect">
             <a:avLst/>
@@ -8977,177 +7864,33 @@
           </a:p>
         </p:txBody>
       </p:sp>
-      <p:sp>
-        <p:nvSpPr>
-          <p:cNvPr id="20" name="TextBox 19"/>
-          <p:cNvSpPr txBox="1"/>
-          <p:nvPr/>
-        </p:nvSpPr>
-        <p:spPr>
-          <a:xfrm>
-            <a:off x="7882127" y="1664208"/>
-            <a:ext cx="3063240" cy="320040"/>
-          </a:xfrm>
-          <a:prstGeom prst="rect">
-            <a:avLst/>
-          </a:prstGeom>
-          <a:noFill/>
-        </p:spPr>
-        <p:txBody>
-          <a:bodyPr wrap="square" lIns="54864" rIns="54864" tIns="27432" bIns="27432">
-            <a:spAutoFit/>
-          </a:bodyPr>
-          <a:lstStyle/>
-          <a:p>
-            <a:pPr algn="l"/>
-            <a:r>
-              <a:rPr sz="1400" b="1" i="0">
-                <a:solidFill>
-                  <a:srgbClr val="15304C"/>
-                </a:solidFill>
-                <a:latin typeface="Calibri"/>
-              </a:rPr>
-              <a:t>Insight</a:t>
-            </a:r>
-          </a:p>
-        </p:txBody>
-      </p:sp>
-      <p:sp>
-        <p:nvSpPr>
-          <p:cNvPr id="21" name="TextBox 20"/>
-          <p:cNvSpPr txBox="1"/>
-          <p:nvPr/>
-        </p:nvSpPr>
-        <p:spPr>
-          <a:xfrm>
-            <a:off x="7882127" y="2084831"/>
-            <a:ext cx="3054096" cy="841248"/>
-          </a:xfrm>
-          <a:prstGeom prst="rect">
-            <a:avLst/>
-          </a:prstGeom>
-          <a:noFill/>
-        </p:spPr>
-        <p:txBody>
-          <a:bodyPr wrap="square" lIns="54864" rIns="54864" tIns="27432" bIns="27432">
-            <a:spAutoFit/>
-          </a:bodyPr>
-          <a:lstStyle/>
-          <a:p>
-            <a:pPr algn="l"/>
-            <a:r>
-              <a:rPr sz="1200" b="1" i="0">
-                <a:solidFill>
-                  <a:srgbClr val="1F2730"/>
-                </a:solidFill>
-                <a:latin typeface="Calibri"/>
-              </a:rPr>
-              <a:t>Overtime employees have 30.5% attrition rate.</a:t>
-            </a:r>
-          </a:p>
-        </p:txBody>
-      </p:sp>
-      <p:sp>
-        <p:nvSpPr>
-          <p:cNvPr id="22" name="TextBox 21"/>
-          <p:cNvSpPr txBox="1"/>
-          <p:nvPr/>
-        </p:nvSpPr>
-        <p:spPr>
-          <a:xfrm>
-            <a:off x="7845552" y="3127248"/>
-            <a:ext cx="3127248" cy="1920240"/>
-          </a:xfrm>
-          <a:prstGeom prst="rect">
-            <a:avLst/>
-          </a:prstGeom>
-          <a:noFill/>
-        </p:spPr>
-        <p:txBody>
-          <a:bodyPr wrap="square" lIns="36576" rIns="36576" tIns="18288" bIns="18288">
-            <a:spAutoFit/>
-          </a:bodyPr>
-          <a:lstStyle/>
-          <a:p>
-            <a:pPr>
-              <a:spcAft>
-                <a:spcPts val="700"/>
-              </a:spcAft>
-            </a:pPr>
-            <a:r>
-              <a:rPr sz="1000" b="1">
-                <a:solidFill>
-                  <a:srgbClr val="2C65A4"/>
-                </a:solidFill>
-                <a:latin typeface="Calibri"/>
-              </a:rPr>
-              <a:t>- </a:t>
-            </a:r>
-            <a:r>
-              <a:rPr sz="1000">
-                <a:solidFill>
-                  <a:srgbClr val="1F2730"/>
-                </a:solidFill>
-                <a:latin typeface="Calibri"/>
-              </a:rPr>
-              <a:t>Overtime employees have 30.5% attrition rate</a:t>
-            </a:r>
-          </a:p>
-          <a:p>
-            <a:pPr>
-              <a:spcAft>
-                <a:spcPts val="700"/>
-              </a:spcAft>
-            </a:pPr>
-            <a:r>
-              <a:rPr sz="1000" b="1">
-                <a:solidFill>
-                  <a:srgbClr val="2C65A4"/>
-                </a:solidFill>
-                <a:latin typeface="Calibri"/>
-              </a:rPr>
-              <a:t>- </a:t>
-            </a:r>
-            <a:r>
-              <a:rPr sz="1000">
-                <a:solidFill>
-                  <a:srgbClr val="1F2730"/>
-                </a:solidFill>
-                <a:latin typeface="Calibri"/>
-              </a:rPr>
-              <a:t>Manage overtime workload to reduce attrition</a:t>
-            </a:r>
-          </a:p>
-          <a:p>
-            <a:pPr>
-              <a:spcAft>
-                <a:spcPts val="700"/>
-              </a:spcAft>
-            </a:pPr>
-            <a:r>
-              <a:rPr sz="1000" b="1">
-                <a:solidFill>
-                  <a:srgbClr val="2C65A4"/>
-                </a:solidFill>
-                <a:latin typeface="Calibri"/>
-              </a:rPr>
-              <a:t>- </a:t>
-            </a:r>
-            <a:r>
-              <a:rPr sz="1000">
-                <a:solidFill>
-                  <a:srgbClr val="1F2730"/>
-                </a:solidFill>
-                <a:latin typeface="Calibri"/>
-              </a:rPr>
-              <a:t>Attrition Rate by Overtime Status</a:t>
-            </a:r>
-          </a:p>
-        </p:txBody>
-      </p:sp>
-      <p:sp>
-        <p:nvSpPr>
-          <p:cNvPr id="23" name="Rectangle 22"/>
+      <p:pic>
+        <p:nvPicPr>
+          <p:cNvPr id="9" name="Picture 8" descr="figure_2_20260626_181544.png"/>
+          <p:cNvPicPr>
+            <a:picLocks noChangeAspect="1"/>
+          </p:cNvPicPr>
+          <p:nvPr/>
+        </p:nvPicPr>
+        <p:blipFill>
+          <a:blip r:embed="rId2"/>
+          <a:stretch>
+            <a:fillRect/>
+          </a:stretch>
+        </p:blipFill>
+        <p:spPr>
+          <a:xfrm>
+            <a:off x="4846320" y="1583322"/>
+            <a:ext cx="6309360" cy="4102835"/>
+          </a:xfrm>
+          <a:prstGeom prst="rect">
+            <a:avLst/>
+          </a:prstGeom>
+        </p:spPr>
+      </p:pic>
+      <p:sp>
+        <p:nvSpPr>
+          <p:cNvPr id="10" name="Rectangle 9"/>
           <p:cNvSpPr/>
           <p:nvPr/>
         </p:nvSpPr>
@@ -9190,7 +7933,7 @@
       </p:sp>
       <p:sp>
         <p:nvSpPr>
-          <p:cNvPr id="24" name="TextBox 23"/>
+          <p:cNvPr id="11" name="TextBox 10"/>
           <p:cNvSpPr txBox="1"/>
           <p:nvPr/>
         </p:nvSpPr>
@@ -9218,14 +7961,14 @@
                 </a:solidFill>
                 <a:latin typeface="Calibri"/>
               </a:rPr>
-              <a:t>Reducing Preventable Attrition</a:t>
-            </a:r>
-          </a:p>
-        </p:txBody>
-      </p:sp>
-      <p:sp>
-        <p:nvSpPr>
-          <p:cNvPr id="25" name="TextBox 24"/>
+              <a:t>Optimizing Operations with High-Fidelity Weather Intelligence</a:t>
+            </a:r>
+          </a:p>
+        </p:txBody>
+      </p:sp>
+      <p:sp>
+        <p:nvSpPr>
+          <p:cNvPr id="12" name="TextBox 11"/>
           <p:cNvSpPr txBox="1"/>
           <p:nvPr/>
         </p:nvSpPr>
@@ -9314,7 +8057,7 @@
                 </a:solidFill>
                 <a:latin typeface="Calibri"/>
               </a:rPr>
-              <a:t>Sales department has the highest attrition rate (25.8%), followed by HR (23.1%)</a:t>
+              <a:t>Solar radiation follows expected diurnal cycle, peaking at midday hours</a:t>
             </a:r>
           </a:p>
         </p:txBody>
@@ -9409,7 +8152,7 @@
       </p:sp>
       <p:pic>
         <p:nvPicPr>
-          <p:cNvPr id="5" name="Picture 4" descr="figure_1_20260601_235322.png"/>
+          <p:cNvPr id="5" name="Picture 4" descr="figure_3_20260626_181544.png"/>
           <p:cNvPicPr>
             <a:picLocks noChangeAspect="1"/>
           </p:cNvPicPr>
@@ -9423,8 +8166,8 @@
         </p:blipFill>
         <p:spPr>
           <a:xfrm>
-            <a:off x="886967" y="1741931"/>
-            <a:ext cx="6309360" cy="3785616"/>
+            <a:off x="886967" y="1599822"/>
+            <a:ext cx="6309360" cy="4069834"/>
           </a:xfrm>
           <a:prstGeom prst="rect">
             <a:avLst/>
@@ -9541,7 +8284,7 @@
                 </a:solidFill>
                 <a:latin typeface="Calibri"/>
               </a:rPr>
-              <a:t>Sales department has the highest attrition rate (25.8%), followed by HR (23.1%).</a:t>
+              <a:t>Solar radiation follows expected diurnal cycle, peaking at midday hours.</a:t>
             </a:r>
           </a:p>
         </p:txBody>
@@ -9589,7 +8332,7 @@
                 </a:solidFill>
                 <a:latin typeface="Calibri"/>
               </a:rPr>
-              <a:t>Sales department has the highest attrition rate (25.8%), followed by HR (23.1%)</a:t>
+              <a:t>Solar radiation follows expected diurnal cycle, peaking at midday hours</a:t>
             </a:r>
           </a:p>
         </p:txBody>
@@ -9667,7 +8410,7 @@
                 </a:solidFill>
                 <a:latin typeface="Calibri"/>
               </a:rPr>
-              <a:t>Reducing Preventable Attrition</a:t>
+              <a:t>Optimizing Operations with High-Fidelity Weather Intelligence</a:t>
             </a:r>
           </a:p>
         </p:txBody>
@@ -9757,13 +8500,13 @@
           <a:p>
             <a:pPr algn="l"/>
             <a:r>
-              <a:rPr sz="2000" b="1" i="0">
+              <a:rPr sz="2300" b="1" i="0">
                 <a:solidFill>
                   <a:srgbClr val="15304C"/>
                 </a:solidFill>
                 <a:latin typeface="Calibri"/>
               </a:rPr>
-              <a:t>Exploratory tree splits on TotalWorkingYears, JobRole Research Scientist, and Age</a:t>
+              <a:t>Exploratory tree splits on T2M, RH2M, and hour of day</a:t>
             </a:r>
           </a:p>
         </p:txBody>
@@ -9819,8 +8562,8 @@
         </p:nvSpPr>
         <p:spPr>
           <a:xfrm>
-            <a:off x="822960" y="1298448"/>
-            <a:ext cx="10469880" cy="4187952"/>
+            <a:off x="749808" y="1371600"/>
+            <a:ext cx="6583680" cy="4526280"/>
           </a:xfrm>
           <a:prstGeom prst="roundRect">
             <a:avLst/>
@@ -9858,7 +8601,7 @@
       </p:sp>
       <p:pic>
         <p:nvPicPr>
-          <p:cNvPr id="5" name="shared_decision_tree_image" descr="decision_tree_rules_20260601_235322.png"/>
+          <p:cNvPr id="5" name="shared_decision_tree_image" descr="decision_tree_rules_20260626_181544.png"/>
           <p:cNvPicPr>
             <a:picLocks noChangeAspect="1"/>
           </p:cNvPicPr>
@@ -9872,8 +8615,8 @@
         </p:blipFill>
         <p:spPr>
           <a:xfrm>
-            <a:off x="4195080" y="1458467"/>
-            <a:ext cx="3725640" cy="3611880"/>
+            <a:off x="2004336" y="1531619"/>
+            <a:ext cx="4074624" cy="3950208"/>
           </a:xfrm>
           <a:prstGeom prst="rect">
             <a:avLst/>
@@ -9888,8 +8631,8 @@
         </p:nvSpPr>
         <p:spPr>
           <a:xfrm>
-            <a:off x="987552" y="5212080"/>
-            <a:ext cx="10140696" cy="164592"/>
+            <a:off x="914400" y="5623560"/>
+            <a:ext cx="6254496" cy="164592"/>
           </a:xfrm>
           <a:prstGeom prst="rect">
             <a:avLst/>
@@ -9910,7 +8653,7 @@
                 </a:solidFill>
                 <a:latin typeface="Calibri"/>
               </a:rPr>
-              <a:t>Train Accuracy: 88.5% | Test Accuracy: 81.9% | Baseline Accuracy: 83.9%</a:t>
+              <a:t>Train R2: 0.922 | Test R2: 0.922</a:t>
             </a:r>
           </a:p>
         </p:txBody>
@@ -9923,14 +8666,14 @@
         </p:nvSpPr>
         <p:spPr>
           <a:xfrm>
-            <a:off x="960120" y="5614416"/>
-            <a:ext cx="10149840" cy="438912"/>
+            <a:off x="7635240" y="1371600"/>
+            <a:ext cx="3657600" cy="4526280"/>
           </a:xfrm>
           <a:prstGeom prst="roundRect">
             <a:avLst/>
           </a:prstGeom>
           <a:solidFill>
-            <a:srgbClr val="E8EFF7"/>
+            <a:srgbClr val="FFFFFF"/>
           </a:solidFill>
           <a:ln w="7620">
             <a:solidFill>
@@ -9968,8 +8711,8 @@
         </p:nvSpPr>
         <p:spPr>
           <a:xfrm>
-            <a:off x="1115568" y="5705856"/>
-            <a:ext cx="9784080" cy="219456"/>
+            <a:off x="7882127" y="1664208"/>
+            <a:ext cx="3063240" cy="320040"/>
           </a:xfrm>
           <a:prstGeom prst="rect">
             <a:avLst/>
@@ -9982,22 +8725,155 @@
           </a:bodyPr>
           <a:lstStyle/>
           <a:p>
-            <a:pPr algn="ctr"/>
-            <a:r>
-              <a:rPr sz="1100" b="1" i="0">
+            <a:pPr algn="l"/>
+            <a:r>
+              <a:rPr sz="1400" b="1" i="0">
                 <a:solidFill>
                   <a:srgbClr val="15304C"/>
                 </a:solidFill>
                 <a:latin typeface="Calibri"/>
               </a:rPr>
-              <a:t>Explanatory model only: test accuracy 81.9% trails the baseline 83.9%; use the rules to guide investigation, not production prediction.</a:t>
-            </a:r>
-          </a:p>
-        </p:txBody>
-      </p:sp>
-      <p:sp>
-        <p:nvSpPr>
-          <p:cNvPr id="9" name="Rectangle 8"/>
+              <a:t>Insight</a:t>
+            </a:r>
+          </a:p>
+        </p:txBody>
+      </p:sp>
+      <p:sp>
+        <p:nvSpPr>
+          <p:cNvPr id="9" name="TextBox 8"/>
+          <p:cNvSpPr txBox="1"/>
+          <p:nvPr/>
+        </p:nvSpPr>
+        <p:spPr>
+          <a:xfrm>
+            <a:off x="7882127" y="2084831"/>
+            <a:ext cx="3054096" cy="841248"/>
+          </a:xfrm>
+          <a:prstGeom prst="rect">
+            <a:avLst/>
+          </a:prstGeom>
+          <a:noFill/>
+        </p:spPr>
+        <p:txBody>
+          <a:bodyPr wrap="square" lIns="54864" rIns="54864" tIns="27432" bIns="27432">
+            <a:spAutoFit/>
+          </a:bodyPr>
+          <a:lstStyle/>
+          <a:p>
+            <a:pPr algn="l"/>
+            <a:r>
+              <a:rPr sz="1200" b="1" i="0">
+                <a:solidFill>
+                  <a:srgbClr val="1F2730"/>
+                </a:solidFill>
+                <a:latin typeface="Calibri"/>
+              </a:rPr>
+              <a:t>Exploratory screening only: validate precision, recall, F1, and support before operational use.</a:t>
+            </a:r>
+          </a:p>
+        </p:txBody>
+      </p:sp>
+      <p:sp>
+        <p:nvSpPr>
+          <p:cNvPr id="10" name="TextBox 9"/>
+          <p:cNvSpPr txBox="1"/>
+          <p:nvPr/>
+        </p:nvSpPr>
+        <p:spPr>
+          <a:xfrm>
+            <a:off x="7845552" y="3127248"/>
+            <a:ext cx="3127248" cy="1920240"/>
+          </a:xfrm>
+          <a:prstGeom prst="rect">
+            <a:avLst/>
+          </a:prstGeom>
+          <a:noFill/>
+        </p:spPr>
+        <p:txBody>
+          <a:bodyPr wrap="square" lIns="36576" rIns="36576" tIns="18288" bIns="18288">
+            <a:spAutoFit/>
+          </a:bodyPr>
+          <a:lstStyle/>
+          <a:p>
+            <a:pPr>
+              <a:spcAft>
+                <a:spcPts val="700"/>
+              </a:spcAft>
+            </a:pPr>
+            <a:r>
+              <a:rPr sz="1000" b="1">
+                <a:solidFill>
+                  <a:srgbClr val="2C65A4"/>
+                </a:solidFill>
+                <a:latin typeface="Calibri"/>
+              </a:rPr>
+              <a:t>- </a:t>
+            </a:r>
+            <a:r>
+              <a:rPr sz="1000">
+                <a:solidFill>
+                  <a:srgbClr val="1F2730"/>
+                </a:solidFill>
+                <a:latin typeface="Calibri"/>
+              </a:rPr>
+              <a:t>Exploratory tree splits on T2M, RH2M, and hour of day</a:t>
+            </a:r>
+          </a:p>
+          <a:p>
+            <a:pPr>
+              <a:spcAft>
+                <a:spcPts val="700"/>
+              </a:spcAft>
+            </a:pPr>
+            <a:r>
+              <a:rPr sz="1000" b="1">
+                <a:solidFill>
+                  <a:srgbClr val="2C65A4"/>
+                </a:solidFill>
+                <a:latin typeface="Calibri"/>
+              </a:rPr>
+              <a:t>- </a:t>
+            </a:r>
+            <a:r>
+              <a:rPr sz="1000">
+                <a:solidFill>
+                  <a:srgbClr val="1F2730"/>
+                </a:solidFill>
+                <a:latin typeface="Calibri"/>
+              </a:rPr>
+              <a:t>Exploratory screening only: validate precision, recall, F1, and support before operational use.</a:t>
+            </a:r>
+          </a:p>
+          <a:p>
+            <a:pPr>
+              <a:spcAft>
+                <a:spcPts val="700"/>
+              </a:spcAft>
+            </a:pPr>
+            <a:r>
+              <a:rPr sz="1000" b="1">
+                <a:solidFill>
+                  <a:srgbClr val="2C65A4"/>
+                </a:solidFill>
+                <a:latin typeface="Calibri"/>
+              </a:rPr>
+              <a:t>- </a:t>
+            </a:r>
+            <a:r>
+              <a:rPr sz="1000">
+                <a:solidFill>
+                  <a:srgbClr val="1F2730"/>
+                </a:solidFill>
+                <a:latin typeface="Calibri"/>
+              </a:rPr>
+              <a:t>Solar Radiation Prediction Rules</a:t>
+            </a:r>
+          </a:p>
+        </p:txBody>
+      </p:sp>
+      <p:sp>
+        <p:nvSpPr>
+          <p:cNvPr id="11" name="Rectangle 10"/>
           <p:cNvSpPr/>
           <p:nvPr/>
         </p:nvSpPr>
@@ -10040,7 +8916,7 @@
       </p:sp>
       <p:sp>
         <p:nvSpPr>
-          <p:cNvPr id="10" name="TextBox 9"/>
+          <p:cNvPr id="12" name="TextBox 11"/>
           <p:cNvSpPr txBox="1"/>
           <p:nvPr/>
         </p:nvSpPr>
@@ -10068,14 +8944,14 @@
                 </a:solidFill>
                 <a:latin typeface="Calibri"/>
               </a:rPr>
-              <a:t>Reducing Preventable Attrition</a:t>
-            </a:r>
-          </a:p>
-        </p:txBody>
-      </p:sp>
-      <p:sp>
-        <p:nvSpPr>
-          <p:cNvPr id="11" name="TextBox 10"/>
+              <a:t>Optimizing Operations with High-Fidelity Weather Intelligence</a:t>
+            </a:r>
+          </a:p>
+        </p:txBody>
+      </p:sp>
+      <p:sp>
+        <p:nvSpPr>
+          <p:cNvPr id="13" name="TextBox 12"/>
           <p:cNvSpPr txBox="1"/>
           <p:nvPr/>
         </p:nvSpPr>
@@ -10158,13 +9034,13 @@
           <a:p>
             <a:pPr algn="l"/>
             <a:r>
-              <a:rPr sz="2000" b="1" i="0">
+              <a:rPr sz="2300" b="1" i="0">
                 <a:solidFill>
                   <a:srgbClr val="15304C"/>
                 </a:solidFill>
                 <a:latin typeface="Calibri"/>
               </a:rPr>
-              <a:t>Three core evidence-based findings on what drives attrition</a:t>
+              <a:t>Decision tree rules summarize model logic</a:t>
             </a:r>
           </a:p>
         </p:txBody>
@@ -10287,7 +9163,7 @@
                 </a:solidFill>
                 <a:latin typeface="Calibri"/>
               </a:rPr>
-              <a:t>Attrition is predictable and concentrated, driven by specific work conditions rather than diffuse employee dissatisfaction.</a:t>
+              <a:t>Exploratory screening only: validate precision, recall, F1, and support before operational use.</a:t>
             </a:r>
           </a:p>
         </p:txBody>
@@ -10445,7 +9321,7 @@
                 </a:solidFill>
                 <a:latin typeface="Calibri"/>
               </a:rPr>
-              <a:t>Sales department attrition is 25.8%, highest among departments</a:t>
+              <a:t>Decision tree rules summarize model logic</a:t>
             </a:r>
           </a:p>
         </p:txBody>
@@ -10603,172 +9479,14 @@
                 </a:solidFill>
                 <a:latin typeface="Calibri"/>
               </a:rPr>
-              <a:t>Frequent travelers have 24.5% attrition rate</a:t>
-            </a:r>
-          </a:p>
-        </p:txBody>
-      </p:sp>
-      <p:sp>
-        <p:nvSpPr>
-          <p:cNvPr id="14" name="Rounded Rectangle 13"/>
-          <p:cNvSpPr/>
-          <p:nvPr/>
-        </p:nvSpPr>
-        <p:spPr>
-          <a:xfrm>
-            <a:off x="7936992" y="2240280"/>
-            <a:ext cx="3154680" cy="3063240"/>
-          </a:xfrm>
-          <a:prstGeom prst="roundRect">
-            <a:avLst/>
-          </a:prstGeom>
-          <a:solidFill>
-            <a:srgbClr val="FFFFFF"/>
-          </a:solidFill>
-          <a:ln w="7620">
-            <a:solidFill>
-              <a:srgbClr val="D1D7DC"/>
-            </a:solidFill>
-          </a:ln>
-        </p:spPr>
-        <p:style>
-          <a:lnRef idx="1">
-            <a:schemeClr val="accent1"/>
-          </a:lnRef>
-          <a:fillRef idx="3">
-            <a:schemeClr val="accent1"/>
-          </a:fillRef>
-          <a:effectRef idx="2">
-            <a:schemeClr val="accent1"/>
-          </a:effectRef>
-          <a:fontRef idx="minor">
-            <a:schemeClr val="lt1"/>
-          </a:fontRef>
-        </p:style>
-        <p:txBody>
-          <a:bodyPr rtlCol="0" anchor="ctr"/>
-          <a:lstStyle/>
-          <a:p>
-            <a:pPr algn="ctr"/>
-          </a:p>
-        </p:txBody>
-      </p:sp>
-      <p:sp>
-        <p:nvSpPr>
-          <p:cNvPr id="15" name="Rectangle 14"/>
-          <p:cNvSpPr/>
-          <p:nvPr/>
-        </p:nvSpPr>
-        <p:spPr>
-          <a:xfrm>
-            <a:off x="7936992" y="2240280"/>
-            <a:ext cx="73152" cy="3063240"/>
-          </a:xfrm>
-          <a:prstGeom prst="rect">
-            <a:avLst/>
-          </a:prstGeom>
-          <a:solidFill>
-            <a:srgbClr val="BB9241"/>
-          </a:solidFill>
-          <a:ln>
-            <a:noFill/>
-          </a:ln>
-        </p:spPr>
-        <p:style>
-          <a:lnRef idx="1">
-            <a:schemeClr val="accent1"/>
-          </a:lnRef>
-          <a:fillRef idx="3">
-            <a:schemeClr val="accent1"/>
-          </a:fillRef>
-          <a:effectRef idx="2">
-            <a:schemeClr val="accent1"/>
-          </a:effectRef>
-          <a:fontRef idx="minor">
-            <a:schemeClr val="lt1"/>
-          </a:fontRef>
-        </p:style>
-        <p:txBody>
-          <a:bodyPr rtlCol="0" anchor="ctr"/>
-          <a:lstStyle/>
-          <a:p>
-            <a:pPr algn="ctr"/>
-          </a:p>
-        </p:txBody>
-      </p:sp>
-      <p:sp>
-        <p:nvSpPr>
-          <p:cNvPr id="16" name="TextBox 15"/>
-          <p:cNvSpPr txBox="1"/>
-          <p:nvPr/>
-        </p:nvSpPr>
-        <p:spPr>
-          <a:xfrm>
-            <a:off x="8165592" y="2578608"/>
-            <a:ext cx="2606040" cy="256032"/>
-          </a:xfrm>
-          <a:prstGeom prst="rect">
-            <a:avLst/>
-          </a:prstGeom>
-          <a:noFill/>
-        </p:spPr>
-        <p:txBody>
-          <a:bodyPr wrap="square" lIns="54864" rIns="54864" tIns="27432" bIns="27432">
-            <a:spAutoFit/>
-          </a:bodyPr>
-          <a:lstStyle/>
-          <a:p>
-            <a:pPr algn="l"/>
-            <a:r>
-              <a:rPr sz="1100" b="1" i="0">
-                <a:solidFill>
-                  <a:srgbClr val="5E6974"/>
-                </a:solidFill>
-                <a:latin typeface="Calibri"/>
-              </a:rPr>
-              <a:t>Finding 3</a:t>
-            </a:r>
-          </a:p>
-        </p:txBody>
-      </p:sp>
-      <p:sp>
-        <p:nvSpPr>
-          <p:cNvPr id="17" name="TextBox 16"/>
-          <p:cNvSpPr txBox="1"/>
-          <p:nvPr/>
-        </p:nvSpPr>
-        <p:spPr>
-          <a:xfrm>
-            <a:off x="8165592" y="2999232"/>
-            <a:ext cx="2606040" cy="1280160"/>
-          </a:xfrm>
-          <a:prstGeom prst="rect">
-            <a:avLst/>
-          </a:prstGeom>
-          <a:noFill/>
-        </p:spPr>
-        <p:txBody>
-          <a:bodyPr wrap="square" lIns="54864" rIns="54864" tIns="27432" bIns="27432">
-            <a:spAutoFit/>
-          </a:bodyPr>
-          <a:lstStyle/>
-          <a:p>
-            <a:pPr algn="l"/>
-            <a:r>
-              <a:rPr sz="1200" b="0" i="0">
-                <a:solidFill>
-                  <a:srgbClr val="1F2730"/>
-                </a:solidFill>
-                <a:latin typeface="Calibri"/>
-              </a:rPr>
-              <a:t>Overtime employees have 30.5% attrition rate</a:t>
-            </a:r>
-          </a:p>
-        </p:txBody>
-      </p:sp>
-      <p:sp>
-        <p:nvSpPr>
-          <p:cNvPr id="18" name="Rectangle 17"/>
+              <a:t>Exploratory screening only: validate precision, recall, F1, and support before operational use.</a:t>
+            </a:r>
+          </a:p>
+        </p:txBody>
+      </p:sp>
+      <p:sp>
+        <p:nvSpPr>
+          <p:cNvPr id="14" name="Rectangle 13"/>
           <p:cNvSpPr/>
           <p:nvPr/>
         </p:nvSpPr>
@@ -10811,7 +9529,7 @@
       </p:sp>
       <p:sp>
         <p:nvSpPr>
-          <p:cNvPr id="19" name="TextBox 18"/>
+          <p:cNvPr id="15" name="TextBox 14"/>
           <p:cNvSpPr txBox="1"/>
           <p:nvPr/>
         </p:nvSpPr>
@@ -10839,14 +9557,14 @@
                 </a:solidFill>
                 <a:latin typeface="Calibri"/>
               </a:rPr>
-              <a:t>Reducing Preventable Attrition</a:t>
-            </a:r>
-          </a:p>
-        </p:txBody>
-      </p:sp>
-      <p:sp>
-        <p:nvSpPr>
-          <p:cNvPr id="20" name="TextBox 19"/>
+              <a:t>Optimizing Operations with High-Fidelity Weather Intelligence</a:t>
+            </a:r>
+          </a:p>
+        </p:txBody>
+      </p:sp>
+      <p:sp>
+        <p:nvSpPr>
+          <p:cNvPr id="16" name="TextBox 15"/>
           <p:cNvSpPr txBox="1"/>
           <p:nvPr/>
         </p:nvSpPr>
@@ -11216,7 +9934,7 @@
                 </a:solidFill>
                 <a:latin typeface="Calibri"/>
               </a:rPr>
-              <a:t>Segment employees by model-extracted rule fields: TotalWorkingYears, JobRole Research Scientist, Age</a:t>
+              <a:t>Segment records by model-extracted rule fields: T2M, RH2M, hour of day</a:t>
             </a:r>
           </a:p>
         </p:txBody>
@@ -11374,7 +10092,7 @@
                 </a:solidFill>
                 <a:latin typeface="Calibri"/>
               </a:rPr>
-              <a:t>Use manager and HR review as the channel for high-risk rule segments</a:t>
+              <a:t>Use owner review as the channel for high-risk rule segments</a:t>
             </a:r>
           </a:p>
         </p:txBody>
@@ -11610,7 +10328,7 @@
                 </a:solidFill>
                 <a:latin typeface="Calibri"/>
               </a:rPr>
-              <a:t>Reducing Preventable Attrition</a:t>
+              <a:t>Optimizing Operations with High-Fidelity Weather Intelligence</a:t>
             </a:r>
           </a:p>
         </p:txBody>

</xml_diff>